<commit_message>
fix: Remove quantity_available from UPDATE (computed column), change unit display to Nos.
</commit_message>
<xml_diff>
--- a/IMS_System_Presentation.pptx
+++ b/IMS_System_Presentation.pptx
@@ -5,23 +5,24 @@
     <p:sldMasterId id="2147483648" r:id="rId1"/>
   </p:sldMasterIdLst>
   <p:sldIdLst>
-    <p:sldId id="256" r:id="rId7"/>
-    <p:sldId id="257" r:id="rId8"/>
-    <p:sldId id="258" r:id="rId9"/>
-    <p:sldId id="259" r:id="rId10"/>
-    <p:sldId id="260" r:id="rId11"/>
-    <p:sldId id="261" r:id="rId12"/>
-    <p:sldId id="262" r:id="rId13"/>
-    <p:sldId id="263" r:id="rId14"/>
-    <p:sldId id="264" r:id="rId15"/>
-    <p:sldId id="265" r:id="rId16"/>
-    <p:sldId id="266" r:id="rId17"/>
-    <p:sldId id="267" r:id="rId18"/>
-    <p:sldId id="268" r:id="rId19"/>
-    <p:sldId id="269" r:id="rId20"/>
-    <p:sldId id="270" r:id="rId21"/>
-    <p:sldId id="271" r:id="rId22"/>
-    <p:sldId id="272" r:id="rId23"/>
+    <p:sldId id="256" r:id="rId2"/>
+    <p:sldId id="273" r:id="rId3"/>
+    <p:sldId id="257" r:id="rId4"/>
+    <p:sldId id="258" r:id="rId5"/>
+    <p:sldId id="259" r:id="rId6"/>
+    <p:sldId id="260" r:id="rId7"/>
+    <p:sldId id="261" r:id="rId8"/>
+    <p:sldId id="262" r:id="rId9"/>
+    <p:sldId id="263" r:id="rId10"/>
+    <p:sldId id="264" r:id="rId11"/>
+    <p:sldId id="265" r:id="rId12"/>
+    <p:sldId id="266" r:id="rId13"/>
+    <p:sldId id="267" r:id="rId14"/>
+    <p:sldId id="268" r:id="rId15"/>
+    <p:sldId id="269" r:id="rId16"/>
+    <p:sldId id="270" r:id="rId17"/>
+    <p:sldId id="271" r:id="rId18"/>
+    <p:sldId id="272" r:id="rId19"/>
   </p:sldIdLst>
   <p:sldSz cx="9144000" cy="6858000" type="screen4x3"/>
   <p:notesSz cx="6858000" cy="9144000"/>
@@ -120,6 +121,22 @@
       </a:defRPr>
     </a:lvl9pPr>
   </p:defaultTextStyle>
+  <p:extLst>
+    <p:ext uri="{EFAFB233-063F-42B5-8137-9DF3F51BA10A}">
+      <p15:sldGuideLst xmlns:p15="http://schemas.microsoft.com/office/powerpoint/2012/main">
+        <p15:guide id="1" orient="horz" pos="2160">
+          <p15:clr>
+            <a:srgbClr val="A4A3A4"/>
+          </p15:clr>
+        </p15:guide>
+        <p15:guide id="2" pos="2880">
+          <p15:clr>
+            <a:srgbClr val="A4A3A4"/>
+          </p15:clr>
+        </p15:guide>
+      </p15:sldGuideLst>
+    </p:ext>
+  </p:extLst>
 </p:presentation>
 </file>
 
@@ -161,10 +178,9 @@
           <a:lstStyle/>
           <a:p>
             <a:r>
-              <a:rPr lang="en-US" smtClean="0"/>
+              <a:rPr lang="en-US"/>
               <a:t>Click to edit Master title style</a:t>
             </a:r>
-            <a:endParaRPr lang="en-US"/>
           </a:p>
         </p:txBody>
       </p:sp>
@@ -280,10 +296,9 @@
           </a:lstStyle>
           <a:p>
             <a:r>
-              <a:rPr lang="en-US" smtClean="0"/>
+              <a:rPr lang="en-US"/>
               <a:t>Click to edit Master subtitle style</a:t>
             </a:r>
-            <a:endParaRPr lang="en-US"/>
           </a:p>
         </p:txBody>
       </p:sp>
@@ -304,7 +319,7 @@
           <a:p>
             <a:fld id="{5BCAD085-E8A6-8845-BD4E-CB4CCA059FC4}" type="datetimeFigureOut">
               <a:rPr lang="en-US" smtClean="0"/>
-              <a:t>1/27/13</a:t>
+              <a:t>3/10/2026</a:t>
             </a:fld>
             <a:endParaRPr lang="en-US"/>
           </a:p>
@@ -398,10 +413,9 @@
           <a:lstStyle/>
           <a:p>
             <a:r>
-              <a:rPr lang="en-US" smtClean="0"/>
+              <a:rPr lang="en-US"/>
               <a:t>Click to edit Master title style</a:t>
             </a:r>
-            <a:endParaRPr lang="en-US"/>
           </a:p>
         </p:txBody>
       </p:sp>
@@ -422,38 +436,37 @@
           <a:p>
             <a:pPr lvl="0"/>
             <a:r>
-              <a:rPr lang="en-US" smtClean="0"/>
+              <a:rPr lang="en-US"/>
               <a:t>Click to edit Master text styles</a:t>
             </a:r>
           </a:p>
           <a:p>
             <a:pPr lvl="1"/>
             <a:r>
-              <a:rPr lang="en-US" smtClean="0"/>
+              <a:rPr lang="en-US"/>
               <a:t>Second level</a:t>
             </a:r>
           </a:p>
           <a:p>
             <a:pPr lvl="2"/>
             <a:r>
-              <a:rPr lang="en-US" smtClean="0"/>
+              <a:rPr lang="en-US"/>
               <a:t>Third level</a:t>
             </a:r>
           </a:p>
           <a:p>
             <a:pPr lvl="3"/>
             <a:r>
-              <a:rPr lang="en-US" smtClean="0"/>
+              <a:rPr lang="en-US"/>
               <a:t>Fourth level</a:t>
             </a:r>
           </a:p>
           <a:p>
             <a:pPr lvl="4"/>
             <a:r>
-              <a:rPr lang="en-US" smtClean="0"/>
+              <a:rPr lang="en-US"/>
               <a:t>Fifth level</a:t>
             </a:r>
-            <a:endParaRPr lang="en-US"/>
           </a:p>
         </p:txBody>
       </p:sp>
@@ -474,7 +487,7 @@
           <a:p>
             <a:fld id="{5BCAD085-E8A6-8845-BD4E-CB4CCA059FC4}" type="datetimeFigureOut">
               <a:rPr lang="en-US" smtClean="0"/>
-              <a:t>1/27/13</a:t>
+              <a:t>3/10/2026</a:t>
             </a:fld>
             <a:endParaRPr lang="en-US"/>
           </a:p>
@@ -573,10 +586,9 @@
           <a:lstStyle/>
           <a:p>
             <a:r>
-              <a:rPr lang="en-US" smtClean="0"/>
+              <a:rPr lang="en-US"/>
               <a:t>Click to edit Master title style</a:t>
             </a:r>
-            <a:endParaRPr lang="en-US"/>
           </a:p>
         </p:txBody>
       </p:sp>
@@ -602,38 +614,37 @@
           <a:p>
             <a:pPr lvl="0"/>
             <a:r>
-              <a:rPr lang="en-US" smtClean="0"/>
+              <a:rPr lang="en-US"/>
               <a:t>Click to edit Master text styles</a:t>
             </a:r>
           </a:p>
           <a:p>
             <a:pPr lvl="1"/>
             <a:r>
-              <a:rPr lang="en-US" smtClean="0"/>
+              <a:rPr lang="en-US"/>
               <a:t>Second level</a:t>
             </a:r>
           </a:p>
           <a:p>
             <a:pPr lvl="2"/>
             <a:r>
-              <a:rPr lang="en-US" smtClean="0"/>
+              <a:rPr lang="en-US"/>
               <a:t>Third level</a:t>
             </a:r>
           </a:p>
           <a:p>
             <a:pPr lvl="3"/>
             <a:r>
-              <a:rPr lang="en-US" smtClean="0"/>
+              <a:rPr lang="en-US"/>
               <a:t>Fourth level</a:t>
             </a:r>
           </a:p>
           <a:p>
             <a:pPr lvl="4"/>
             <a:r>
-              <a:rPr lang="en-US" smtClean="0"/>
+              <a:rPr lang="en-US"/>
               <a:t>Fifth level</a:t>
             </a:r>
-            <a:endParaRPr lang="en-US"/>
           </a:p>
         </p:txBody>
       </p:sp>
@@ -654,7 +665,7 @@
           <a:p>
             <a:fld id="{5BCAD085-E8A6-8845-BD4E-CB4CCA059FC4}" type="datetimeFigureOut">
               <a:rPr lang="en-US" smtClean="0"/>
-              <a:t>1/27/13</a:t>
+              <a:t>3/10/2026</a:t>
             </a:fld>
             <a:endParaRPr lang="en-US"/>
           </a:p>
@@ -748,10 +759,9 @@
           <a:lstStyle/>
           <a:p>
             <a:r>
-              <a:rPr lang="en-US" smtClean="0"/>
+              <a:rPr lang="en-US"/>
               <a:t>Click to edit Master title style</a:t>
             </a:r>
-            <a:endParaRPr lang="en-US"/>
           </a:p>
         </p:txBody>
       </p:sp>
@@ -772,38 +782,37 @@
           <a:p>
             <a:pPr lvl="0"/>
             <a:r>
-              <a:rPr lang="en-US" smtClean="0"/>
+              <a:rPr lang="en-US"/>
               <a:t>Click to edit Master text styles</a:t>
             </a:r>
           </a:p>
           <a:p>
             <a:pPr lvl="1"/>
             <a:r>
-              <a:rPr lang="en-US" smtClean="0"/>
+              <a:rPr lang="en-US"/>
               <a:t>Second level</a:t>
             </a:r>
           </a:p>
           <a:p>
             <a:pPr lvl="2"/>
             <a:r>
-              <a:rPr lang="en-US" smtClean="0"/>
+              <a:rPr lang="en-US"/>
               <a:t>Third level</a:t>
             </a:r>
           </a:p>
           <a:p>
             <a:pPr lvl="3"/>
             <a:r>
-              <a:rPr lang="en-US" smtClean="0"/>
+              <a:rPr lang="en-US"/>
               <a:t>Fourth level</a:t>
             </a:r>
           </a:p>
           <a:p>
             <a:pPr lvl="4"/>
             <a:r>
-              <a:rPr lang="en-US" smtClean="0"/>
+              <a:rPr lang="en-US"/>
               <a:t>Fifth level</a:t>
             </a:r>
-            <a:endParaRPr lang="en-US"/>
           </a:p>
         </p:txBody>
       </p:sp>
@@ -824,7 +833,7 @@
           <a:p>
             <a:fld id="{5BCAD085-E8A6-8845-BD4E-CB4CCA059FC4}" type="datetimeFigureOut">
               <a:rPr lang="en-US" smtClean="0"/>
-              <a:t>1/27/13</a:t>
+              <a:t>3/10/2026</a:t>
             </a:fld>
             <a:endParaRPr lang="en-US"/>
           </a:p>
@@ -927,10 +936,9 @@
           </a:lstStyle>
           <a:p>
             <a:r>
-              <a:rPr lang="en-US" smtClean="0"/>
+              <a:rPr lang="en-US"/>
               <a:t>Click to edit Master title style</a:t>
             </a:r>
-            <a:endParaRPr lang="en-US"/>
           </a:p>
         </p:txBody>
       </p:sp>
@@ -1047,7 +1055,7 @@
           <a:p>
             <a:pPr lvl="0"/>
             <a:r>
-              <a:rPr lang="en-US" smtClean="0"/>
+              <a:rPr lang="en-US"/>
               <a:t>Click to edit Master text styles</a:t>
             </a:r>
           </a:p>
@@ -1070,7 +1078,7 @@
           <a:p>
             <a:fld id="{5BCAD085-E8A6-8845-BD4E-CB4CCA059FC4}" type="datetimeFigureOut">
               <a:rPr lang="en-US" smtClean="0"/>
-              <a:t>1/27/13</a:t>
+              <a:t>3/10/2026</a:t>
             </a:fld>
             <a:endParaRPr lang="en-US"/>
           </a:p>
@@ -1164,10 +1172,9 @@
           <a:lstStyle/>
           <a:p>
             <a:r>
-              <a:rPr lang="en-US" smtClean="0"/>
+              <a:rPr lang="en-US"/>
               <a:t>Click to edit Master title style</a:t>
             </a:r>
-            <a:endParaRPr lang="en-US"/>
           </a:p>
         </p:txBody>
       </p:sp>
@@ -1221,38 +1228,37 @@
           <a:p>
             <a:pPr lvl="0"/>
             <a:r>
-              <a:rPr lang="en-US" smtClean="0"/>
+              <a:rPr lang="en-US"/>
               <a:t>Click to edit Master text styles</a:t>
             </a:r>
           </a:p>
           <a:p>
             <a:pPr lvl="1"/>
             <a:r>
-              <a:rPr lang="en-US" smtClean="0"/>
+              <a:rPr lang="en-US"/>
               <a:t>Second level</a:t>
             </a:r>
           </a:p>
           <a:p>
             <a:pPr lvl="2"/>
             <a:r>
-              <a:rPr lang="en-US" smtClean="0"/>
+              <a:rPr lang="en-US"/>
               <a:t>Third level</a:t>
             </a:r>
           </a:p>
           <a:p>
             <a:pPr lvl="3"/>
             <a:r>
-              <a:rPr lang="en-US" smtClean="0"/>
+              <a:rPr lang="en-US"/>
               <a:t>Fourth level</a:t>
             </a:r>
           </a:p>
           <a:p>
             <a:pPr lvl="4"/>
             <a:r>
-              <a:rPr lang="en-US" smtClean="0"/>
+              <a:rPr lang="en-US"/>
               <a:t>Fifth level</a:t>
             </a:r>
-            <a:endParaRPr lang="en-US"/>
           </a:p>
         </p:txBody>
       </p:sp>
@@ -1306,38 +1312,37 @@
           <a:p>
             <a:pPr lvl="0"/>
             <a:r>
-              <a:rPr lang="en-US" smtClean="0"/>
+              <a:rPr lang="en-US"/>
               <a:t>Click to edit Master text styles</a:t>
             </a:r>
           </a:p>
           <a:p>
             <a:pPr lvl="1"/>
             <a:r>
-              <a:rPr lang="en-US" smtClean="0"/>
+              <a:rPr lang="en-US"/>
               <a:t>Second level</a:t>
             </a:r>
           </a:p>
           <a:p>
             <a:pPr lvl="2"/>
             <a:r>
-              <a:rPr lang="en-US" smtClean="0"/>
+              <a:rPr lang="en-US"/>
               <a:t>Third level</a:t>
             </a:r>
           </a:p>
           <a:p>
             <a:pPr lvl="3"/>
             <a:r>
-              <a:rPr lang="en-US" smtClean="0"/>
+              <a:rPr lang="en-US"/>
               <a:t>Fourth level</a:t>
             </a:r>
           </a:p>
           <a:p>
             <a:pPr lvl="4"/>
             <a:r>
-              <a:rPr lang="en-US" smtClean="0"/>
+              <a:rPr lang="en-US"/>
               <a:t>Fifth level</a:t>
             </a:r>
-            <a:endParaRPr lang="en-US"/>
           </a:p>
         </p:txBody>
       </p:sp>
@@ -1358,7 +1363,7 @@
           <a:p>
             <a:fld id="{5BCAD085-E8A6-8845-BD4E-CB4CCA059FC4}" type="datetimeFigureOut">
               <a:rPr lang="en-US" smtClean="0"/>
-              <a:t>1/27/13</a:t>
+              <a:t>3/10/2026</a:t>
             </a:fld>
             <a:endParaRPr lang="en-US"/>
           </a:p>
@@ -1456,10 +1461,9 @@
           </a:lstStyle>
           <a:p>
             <a:r>
-              <a:rPr lang="en-US" smtClean="0"/>
+              <a:rPr lang="en-US"/>
               <a:t>Click to edit Master title style</a:t>
             </a:r>
-            <a:endParaRPr lang="en-US"/>
           </a:p>
         </p:txBody>
       </p:sp>
@@ -1522,7 +1526,7 @@
           <a:p>
             <a:pPr lvl="0"/>
             <a:r>
-              <a:rPr lang="en-US" smtClean="0"/>
+              <a:rPr lang="en-US"/>
               <a:t>Click to edit Master text styles</a:t>
             </a:r>
           </a:p>
@@ -1578,38 +1582,37 @@
           <a:p>
             <a:pPr lvl="0"/>
             <a:r>
-              <a:rPr lang="en-US" smtClean="0"/>
+              <a:rPr lang="en-US"/>
               <a:t>Click to edit Master text styles</a:t>
             </a:r>
           </a:p>
           <a:p>
             <a:pPr lvl="1"/>
             <a:r>
-              <a:rPr lang="en-US" smtClean="0"/>
+              <a:rPr lang="en-US"/>
               <a:t>Second level</a:t>
             </a:r>
           </a:p>
           <a:p>
             <a:pPr lvl="2"/>
             <a:r>
-              <a:rPr lang="en-US" smtClean="0"/>
+              <a:rPr lang="en-US"/>
               <a:t>Third level</a:t>
             </a:r>
           </a:p>
           <a:p>
             <a:pPr lvl="3"/>
             <a:r>
-              <a:rPr lang="en-US" smtClean="0"/>
+              <a:rPr lang="en-US"/>
               <a:t>Fourth level</a:t>
             </a:r>
           </a:p>
           <a:p>
             <a:pPr lvl="4"/>
             <a:r>
-              <a:rPr lang="en-US" smtClean="0"/>
+              <a:rPr lang="en-US"/>
               <a:t>Fifth level</a:t>
             </a:r>
-            <a:endParaRPr lang="en-US"/>
           </a:p>
         </p:txBody>
       </p:sp>
@@ -1672,7 +1675,7 @@
           <a:p>
             <a:pPr lvl="0"/>
             <a:r>
-              <a:rPr lang="en-US" smtClean="0"/>
+              <a:rPr lang="en-US"/>
               <a:t>Click to edit Master text styles</a:t>
             </a:r>
           </a:p>
@@ -1728,38 +1731,37 @@
           <a:p>
             <a:pPr lvl="0"/>
             <a:r>
-              <a:rPr lang="en-US" smtClean="0"/>
+              <a:rPr lang="en-US"/>
               <a:t>Click to edit Master text styles</a:t>
             </a:r>
           </a:p>
           <a:p>
             <a:pPr lvl="1"/>
             <a:r>
-              <a:rPr lang="en-US" smtClean="0"/>
+              <a:rPr lang="en-US"/>
               <a:t>Second level</a:t>
             </a:r>
           </a:p>
           <a:p>
             <a:pPr lvl="2"/>
             <a:r>
-              <a:rPr lang="en-US" smtClean="0"/>
+              <a:rPr lang="en-US"/>
               <a:t>Third level</a:t>
             </a:r>
           </a:p>
           <a:p>
             <a:pPr lvl="3"/>
             <a:r>
-              <a:rPr lang="en-US" smtClean="0"/>
+              <a:rPr lang="en-US"/>
               <a:t>Fourth level</a:t>
             </a:r>
           </a:p>
           <a:p>
             <a:pPr lvl="4"/>
             <a:r>
-              <a:rPr lang="en-US" smtClean="0"/>
+              <a:rPr lang="en-US"/>
               <a:t>Fifth level</a:t>
             </a:r>
-            <a:endParaRPr lang="en-US"/>
           </a:p>
         </p:txBody>
       </p:sp>
@@ -1780,7 +1782,7 @@
           <a:p>
             <a:fld id="{5BCAD085-E8A6-8845-BD4E-CB4CCA059FC4}" type="datetimeFigureOut">
               <a:rPr lang="en-US" smtClean="0"/>
-              <a:t>1/27/13</a:t>
+              <a:t>3/10/2026</a:t>
             </a:fld>
             <a:endParaRPr lang="en-US"/>
           </a:p>
@@ -1874,10 +1876,9 @@
           <a:lstStyle/>
           <a:p>
             <a:r>
-              <a:rPr lang="en-US" smtClean="0"/>
+              <a:rPr lang="en-US"/>
               <a:t>Click to edit Master title style</a:t>
             </a:r>
-            <a:endParaRPr lang="en-US"/>
           </a:p>
         </p:txBody>
       </p:sp>
@@ -1898,7 +1899,7 @@
           <a:p>
             <a:fld id="{5BCAD085-E8A6-8845-BD4E-CB4CCA059FC4}" type="datetimeFigureOut">
               <a:rPr lang="en-US" smtClean="0"/>
-              <a:t>1/27/13</a:t>
+              <a:t>3/10/2026</a:t>
             </a:fld>
             <a:endParaRPr lang="en-US"/>
           </a:p>
@@ -1993,7 +1994,7 @@
           <a:p>
             <a:fld id="{5BCAD085-E8A6-8845-BD4E-CB4CCA059FC4}" type="datetimeFigureOut">
               <a:rPr lang="en-US" smtClean="0"/>
-              <a:t>1/27/13</a:t>
+              <a:t>3/10/2026</a:t>
             </a:fld>
             <a:endParaRPr lang="en-US"/>
           </a:p>
@@ -2096,10 +2097,9 @@
           </a:lstStyle>
           <a:p>
             <a:r>
-              <a:rPr lang="en-US" smtClean="0"/>
+              <a:rPr lang="en-US"/>
               <a:t>Click to edit Master title style</a:t>
             </a:r>
-            <a:endParaRPr lang="en-US"/>
           </a:p>
         </p:txBody>
       </p:sp>
@@ -2153,38 +2153,37 @@
           <a:p>
             <a:pPr lvl="0"/>
             <a:r>
-              <a:rPr lang="en-US" smtClean="0"/>
+              <a:rPr lang="en-US"/>
               <a:t>Click to edit Master text styles</a:t>
             </a:r>
           </a:p>
           <a:p>
             <a:pPr lvl="1"/>
             <a:r>
-              <a:rPr lang="en-US" smtClean="0"/>
+              <a:rPr lang="en-US"/>
               <a:t>Second level</a:t>
             </a:r>
           </a:p>
           <a:p>
             <a:pPr lvl="2"/>
             <a:r>
-              <a:rPr lang="en-US" smtClean="0"/>
+              <a:rPr lang="en-US"/>
               <a:t>Third level</a:t>
             </a:r>
           </a:p>
           <a:p>
             <a:pPr lvl="3"/>
             <a:r>
-              <a:rPr lang="en-US" smtClean="0"/>
+              <a:rPr lang="en-US"/>
               <a:t>Fourth level</a:t>
             </a:r>
           </a:p>
           <a:p>
             <a:pPr lvl="4"/>
             <a:r>
-              <a:rPr lang="en-US" smtClean="0"/>
+              <a:rPr lang="en-US"/>
               <a:t>Fifth level</a:t>
             </a:r>
-            <a:endParaRPr lang="en-US"/>
           </a:p>
         </p:txBody>
       </p:sp>
@@ -2247,7 +2246,7 @@
           <a:p>
             <a:pPr lvl="0"/>
             <a:r>
-              <a:rPr lang="en-US" smtClean="0"/>
+              <a:rPr lang="en-US"/>
               <a:t>Click to edit Master text styles</a:t>
             </a:r>
           </a:p>
@@ -2270,7 +2269,7 @@
           <a:p>
             <a:fld id="{5BCAD085-E8A6-8845-BD4E-CB4CCA059FC4}" type="datetimeFigureOut">
               <a:rPr lang="en-US" smtClean="0"/>
-              <a:t>1/27/13</a:t>
+              <a:t>3/10/2026</a:t>
             </a:fld>
             <a:endParaRPr lang="en-US"/>
           </a:p>
@@ -2373,10 +2372,9 @@
           </a:lstStyle>
           <a:p>
             <a:r>
-              <a:rPr lang="en-US" smtClean="0"/>
+              <a:rPr lang="en-US"/>
               <a:t>Click to edit Master title style</a:t>
             </a:r>
-            <a:endParaRPr lang="en-US"/>
           </a:p>
         </p:txBody>
       </p:sp>
@@ -2500,7 +2498,7 @@
           <a:p>
             <a:pPr lvl="0"/>
             <a:r>
-              <a:rPr lang="en-US" smtClean="0"/>
+              <a:rPr lang="en-US"/>
               <a:t>Click to edit Master text styles</a:t>
             </a:r>
           </a:p>
@@ -2523,7 +2521,7 @@
           <a:p>
             <a:fld id="{5BCAD085-E8A6-8845-BD4E-CB4CCA059FC4}" type="datetimeFigureOut">
               <a:rPr lang="en-US" smtClean="0"/>
-              <a:t>1/27/13</a:t>
+              <a:t>3/10/2026</a:t>
             </a:fld>
             <a:endParaRPr lang="en-US"/>
           </a:p>
@@ -2632,10 +2630,9 @@
           <a:lstStyle/>
           <a:p>
             <a:r>
-              <a:rPr lang="en-US" smtClean="0"/>
+              <a:rPr lang="en-US"/>
               <a:t>Click to edit Master title style</a:t>
             </a:r>
-            <a:endParaRPr lang="en-US"/>
           </a:p>
         </p:txBody>
       </p:sp>
@@ -2666,38 +2663,37 @@
           <a:p>
             <a:pPr lvl="0"/>
             <a:r>
-              <a:rPr lang="en-US" smtClean="0"/>
+              <a:rPr lang="en-US"/>
               <a:t>Click to edit Master text styles</a:t>
             </a:r>
           </a:p>
           <a:p>
             <a:pPr lvl="1"/>
             <a:r>
-              <a:rPr lang="en-US" smtClean="0"/>
+              <a:rPr lang="en-US"/>
               <a:t>Second level</a:t>
             </a:r>
           </a:p>
           <a:p>
             <a:pPr lvl="2"/>
             <a:r>
-              <a:rPr lang="en-US" smtClean="0"/>
+              <a:rPr lang="en-US"/>
               <a:t>Third level</a:t>
             </a:r>
           </a:p>
           <a:p>
             <a:pPr lvl="3"/>
             <a:r>
-              <a:rPr lang="en-US" smtClean="0"/>
+              <a:rPr lang="en-US"/>
               <a:t>Fourth level</a:t>
             </a:r>
           </a:p>
           <a:p>
             <a:pPr lvl="4"/>
             <a:r>
-              <a:rPr lang="en-US" smtClean="0"/>
+              <a:rPr lang="en-US"/>
               <a:t>Fifth level</a:t>
             </a:r>
-            <a:endParaRPr lang="en-US"/>
           </a:p>
         </p:txBody>
       </p:sp>
@@ -2736,7 +2732,7 @@
           <a:p>
             <a:fld id="{5BCAD085-E8A6-8845-BD4E-CB4CCA059FC4}" type="datetimeFigureOut">
               <a:rPr lang="en-US" smtClean="0"/>
-              <a:t>1/27/13</a:t>
+              <a:t>3/10/2026</a:t>
             </a:fld>
             <a:endParaRPr lang="en-US"/>
           </a:p>
@@ -3095,12 +3091,12 @@
 </file>
 
 <file path=ppt/slides/slide1.xml><?xml version="1.0" encoding="utf-8"?>
-<p:sld xmlns:a="http://schemas.openxmlformats.org/drawingml/2006/main" xmlns:p="http://schemas.openxmlformats.org/presentationml/2006/main" xmlns:r="http://schemas.openxmlformats.org/officeDocument/2006/relationships">
+<p:sld xmlns:a="http://schemas.openxmlformats.org/drawingml/2006/main" xmlns:r="http://schemas.openxmlformats.org/officeDocument/2006/relationships" xmlns:p="http://schemas.openxmlformats.org/presentationml/2006/main">
   <p:cSld>
     <p:bg>
       <p:bgPr>
         <a:solidFill>
-          <a:srgbClr val="1F4E79"/>
+          <a:schemeClr val="bg1"/>
         </a:solidFill>
         <a:effectLst/>
       </p:bgPr>
@@ -3111,65 +3107,507 @@
         <p:cNvGrpSpPr/>
         <p:nvPr/>
       </p:nvGrpSpPr>
-      <p:grpSpPr/>
-      <p:sp>
-        <p:nvSpPr>
-          <p:cNvPr id="2" name="TextBox 1"/>
-          <p:cNvSpPr txBox="1"/>
+      <p:grpSpPr>
+        <a:xfrm>
+          <a:off x="0" y="0"/>
+          <a:ext cx="0" cy="0"/>
+          <a:chOff x="0" y="0"/>
+          <a:chExt cx="0" cy="0"/>
+        </a:xfrm>
+      </p:grpSpPr>
+      <p:pic>
+        <p:nvPicPr>
+          <p:cNvPr id="5" name="Picture 4" descr="Person writing on a notepad">
+            <a:extLst>
+              <a:ext uri="{FF2B5EF4-FFF2-40B4-BE49-F238E27FC236}">
+                <a16:creationId xmlns:a16="http://schemas.microsoft.com/office/drawing/2014/main" id="{249E2E72-5DF0-3378-B155-AB86B5683A7A}"/>
+              </a:ext>
+            </a:extLst>
+          </p:cNvPr>
+          <p:cNvPicPr>
+            <a:picLocks noChangeAspect="1"/>
+          </p:cNvPicPr>
           <p:nvPr/>
-        </p:nvSpPr>
+        </p:nvPicPr>
+        <p:blipFill>
+          <a:blip r:embed="rId2"/>
+          <a:srcRect t="2545" r="-2" b="2543"/>
+          <a:stretch>
+            <a:fillRect/>
+          </a:stretch>
+        </p:blipFill>
         <p:spPr>
           <a:xfrm>
-            <a:off x="457200" y="2286000"/>
-            <a:ext cx="8229600" cy="1828800"/>
+            <a:off x="-2585" y="-1"/>
+            <a:ext cx="9146585" cy="6879745"/>
           </a:xfrm>
           <a:prstGeom prst="rect">
             <a:avLst/>
           </a:prstGeom>
-          <a:noFill/>
         </p:spPr>
-        <p:txBody>
-          <a:bodyPr wrap="square">
-            <a:spAutoFit/>
-          </a:bodyPr>
-          <a:lstStyle/>
-          <a:p>
-            <a:pPr algn="ctr">
-              <a:defRPr sz="5400" b="1">
-                <a:solidFill>
-                  <a:srgbClr val="FFFFFF"/>
-                </a:solidFill>
-              </a:defRPr>
-            </a:pPr>
-            <a:r>
-              <a:t>INVENTORY MANAGEMENT SYSTEM</a:t>
-            </a:r>
-          </a:p>
-        </p:txBody>
-      </p:sp>
-      <p:sp>
-        <p:nvSpPr>
-          <p:cNvPr id="3" name="TextBox 2"/>
-          <p:cNvSpPr txBox="1"/>
-          <p:nvPr/>
+      </p:pic>
+      <p:sp>
+        <p:nvSpPr>
+          <p:cNvPr id="18" name="Rectangle 17">
+            <a:extLst>
+              <a:ext uri="{FF2B5EF4-FFF2-40B4-BE49-F238E27FC236}">
+                <a16:creationId xmlns:a16="http://schemas.microsoft.com/office/drawing/2014/main" id="{4D60F200-5EB0-B223-2439-C96C67F0FEE1}"/>
+              </a:ext>
+              <a:ext uri="{C183D7F6-B498-43B3-948B-1728B52AA6E4}">
+                <adec:decorative xmlns:adec="http://schemas.microsoft.com/office/drawing/2017/decorative" val="1"/>
+              </a:ext>
+            </a:extLst>
+          </p:cNvPr>
+          <p:cNvSpPr>
+            <a:spLocks noGrp="1" noRot="1" noChangeAspect="1" noMove="1" noResize="1" noEditPoints="1" noAdjustHandles="1" noChangeArrowheads="1" noChangeShapeType="1" noTextEdit="1"/>
+          </p:cNvSpPr>
+          <p:nvPr>
+            <p:extLst>
+              <p:ext uri="{386F3935-93C4-4BCD-93E2-E3B085C9AB24}">
+                <p16:designElem xmlns:p16="http://schemas.microsoft.com/office/powerpoint/2015/main" val="1"/>
+              </p:ext>
+            </p:extLst>
+          </p:nvPr>
         </p:nvSpPr>
         <p:spPr>
-          <a:xfrm>
-            <a:off x="457200" y="4389120"/>
-            <a:ext cx="8229600" cy="1371600"/>
+          <a:xfrm rot="16200000">
+            <a:off x="3064451" y="791834"/>
+            <a:ext cx="3020876" cy="9154947"/>
           </a:xfrm>
           <a:prstGeom prst="rect">
             <a:avLst/>
           </a:prstGeom>
-          <a:noFill/>
+          <a:gradFill flip="none" rotWithShape="1">
+            <a:gsLst>
+              <a:gs pos="21000">
+                <a:srgbClr val="000000">
+                  <a:alpha val="62000"/>
+                </a:srgbClr>
+              </a:gs>
+              <a:gs pos="100000">
+                <a:srgbClr val="000000">
+                  <a:alpha val="0"/>
+                </a:srgbClr>
+              </a:gs>
+            </a:gsLst>
+            <a:lin ang="0" scaled="0"/>
+            <a:tileRect/>
+          </a:gradFill>
+          <a:ln>
+            <a:noFill/>
+          </a:ln>
         </p:spPr>
-        <p:txBody>
-          <a:bodyPr wrap="square">
-            <a:spAutoFit/>
+        <p:style>
+          <a:lnRef idx="2">
+            <a:schemeClr val="accent1">
+              <a:shade val="50000"/>
+            </a:schemeClr>
+          </a:lnRef>
+          <a:fillRef idx="1">
+            <a:schemeClr val="accent1"/>
+          </a:fillRef>
+          <a:effectRef idx="0">
+            <a:schemeClr val="accent1"/>
+          </a:effectRef>
+          <a:fontRef idx="minor">
+            <a:schemeClr val="lt1"/>
+          </a:fontRef>
+        </p:style>
+        <p:txBody>
+          <a:bodyPr rtlCol="0" anchor="ctr"/>
+          <a:lstStyle/>
+          <a:p>
+            <a:pPr algn="ctr"/>
+            <a:endParaRPr lang="en-US"/>
+          </a:p>
+        </p:txBody>
+      </p:sp>
+      <p:sp>
+        <p:nvSpPr>
+          <p:cNvPr id="20" name="Rectangle 19">
+            <a:extLst>
+              <a:ext uri="{FF2B5EF4-FFF2-40B4-BE49-F238E27FC236}">
+                <a16:creationId xmlns:a16="http://schemas.microsoft.com/office/drawing/2014/main" id="{A6567EA8-C72D-4B9B-D23F-6B2E9F9C9F47}"/>
+              </a:ext>
+              <a:ext uri="{C183D7F6-B498-43B3-948B-1728B52AA6E4}">
+                <adec:decorative xmlns:adec="http://schemas.microsoft.com/office/drawing/2017/decorative" val="1"/>
+              </a:ext>
+            </a:extLst>
+          </p:cNvPr>
+          <p:cNvSpPr>
+            <a:spLocks noGrp="1" noRot="1" noChangeAspect="1" noMove="1" noResize="1" noEditPoints="1" noAdjustHandles="1" noChangeArrowheads="1" noChangeShapeType="1" noTextEdit="1"/>
+          </p:cNvSpPr>
+          <p:nvPr>
+            <p:extLst>
+              <p:ext uri="{386F3935-93C4-4BCD-93E2-E3B085C9AB24}">
+                <p16:designElem xmlns:p16="http://schemas.microsoft.com/office/powerpoint/2015/main" val="1"/>
+              </p:ext>
+            </p:extLst>
+          </p:nvPr>
+        </p:nvSpPr>
+        <p:spPr>
+          <a:xfrm rot="10800000">
+            <a:off x="-2584" y="0"/>
+            <a:ext cx="2132551" cy="6879745"/>
+          </a:xfrm>
+          <a:prstGeom prst="rect">
+            <a:avLst/>
+          </a:prstGeom>
+          <a:gradFill flip="none" rotWithShape="1">
+            <a:gsLst>
+              <a:gs pos="5000">
+                <a:schemeClr val="accent2"/>
+              </a:gs>
+              <a:gs pos="49000">
+                <a:schemeClr val="accent5">
+                  <a:lumMod val="60000"/>
+                  <a:lumOff val="40000"/>
+                  <a:alpha val="0"/>
+                </a:schemeClr>
+              </a:gs>
+            </a:gsLst>
+            <a:lin ang="9600000" scaled="0"/>
+            <a:tileRect/>
+          </a:gradFill>
+          <a:ln>
+            <a:noFill/>
+          </a:ln>
+        </p:spPr>
+        <p:style>
+          <a:lnRef idx="2">
+            <a:schemeClr val="accent1">
+              <a:shade val="50000"/>
+            </a:schemeClr>
+          </a:lnRef>
+          <a:fillRef idx="1">
+            <a:schemeClr val="accent1"/>
+          </a:fillRef>
+          <a:effectRef idx="0">
+            <a:schemeClr val="accent1"/>
+          </a:effectRef>
+          <a:fontRef idx="minor">
+            <a:schemeClr val="lt1"/>
+          </a:fontRef>
+        </p:style>
+        <p:txBody>
+          <a:bodyPr rtlCol="0" anchor="ctr"/>
+          <a:lstStyle/>
+          <a:p>
+            <a:pPr algn="ctr"/>
+            <a:endParaRPr lang="en-US"/>
+          </a:p>
+        </p:txBody>
+      </p:sp>
+      <p:sp>
+        <p:nvSpPr>
+          <p:cNvPr id="22" name="Rectangle 21">
+            <a:extLst>
+              <a:ext uri="{FF2B5EF4-FFF2-40B4-BE49-F238E27FC236}">
+                <a16:creationId xmlns:a16="http://schemas.microsoft.com/office/drawing/2014/main" id="{FEFBFA78-9360-1E01-5448-6D5AE0A32601}"/>
+              </a:ext>
+              <a:ext uri="{C183D7F6-B498-43B3-948B-1728B52AA6E4}">
+                <adec:decorative xmlns:adec="http://schemas.microsoft.com/office/drawing/2017/decorative" val="1"/>
+              </a:ext>
+            </a:extLst>
+          </p:cNvPr>
+          <p:cNvSpPr>
+            <a:spLocks noGrp="1" noRot="1" noChangeAspect="1" noMove="1" noResize="1" noEditPoints="1" noAdjustHandles="1" noChangeArrowheads="1" noChangeShapeType="1" noTextEdit="1"/>
+          </p:cNvSpPr>
+          <p:nvPr>
+            <p:extLst>
+              <p:ext uri="{386F3935-93C4-4BCD-93E2-E3B085C9AB24}">
+                <p16:designElem xmlns:p16="http://schemas.microsoft.com/office/powerpoint/2015/main" val="1"/>
+              </p:ext>
+            </p:extLst>
+          </p:nvPr>
+        </p:nvSpPr>
+        <p:spPr>
+          <a:xfrm rot="10800000">
+            <a:off x="6779028" y="21736"/>
+            <a:ext cx="2364646" cy="6858008"/>
+          </a:xfrm>
+          <a:prstGeom prst="rect">
+            <a:avLst/>
+          </a:prstGeom>
+          <a:gradFill flip="none" rotWithShape="1">
+            <a:gsLst>
+              <a:gs pos="5000">
+                <a:schemeClr val="accent5">
+                  <a:alpha val="48000"/>
+                </a:schemeClr>
+              </a:gs>
+              <a:gs pos="42000">
+                <a:schemeClr val="accent5">
+                  <a:alpha val="0"/>
+                </a:schemeClr>
+              </a:gs>
+            </a:gsLst>
+            <a:lin ang="1800000" scaled="0"/>
+            <a:tileRect/>
+          </a:gradFill>
+          <a:ln>
+            <a:noFill/>
+          </a:ln>
+        </p:spPr>
+        <p:style>
+          <a:lnRef idx="2">
+            <a:schemeClr val="accent1">
+              <a:shade val="50000"/>
+            </a:schemeClr>
+          </a:lnRef>
+          <a:fillRef idx="1">
+            <a:schemeClr val="accent1"/>
+          </a:fillRef>
+          <a:effectRef idx="0">
+            <a:schemeClr val="accent1"/>
+          </a:effectRef>
+          <a:fontRef idx="minor">
+            <a:schemeClr val="lt1"/>
+          </a:fontRef>
+        </p:style>
+        <p:txBody>
+          <a:bodyPr rtlCol="0" anchor="ctr"/>
+          <a:lstStyle/>
+          <a:p>
+            <a:pPr algn="ctr"/>
+            <a:endParaRPr lang="en-US"/>
+          </a:p>
+        </p:txBody>
+      </p:sp>
+      <p:sp>
+        <p:nvSpPr>
+          <p:cNvPr id="24" name="Rectangle 23">
+            <a:extLst>
+              <a:ext uri="{FF2B5EF4-FFF2-40B4-BE49-F238E27FC236}">
+                <a16:creationId xmlns:a16="http://schemas.microsoft.com/office/drawing/2014/main" id="{1740453C-744F-DB3A-47EC-15EACE1DC117}"/>
+              </a:ext>
+              <a:ext uri="{C183D7F6-B498-43B3-948B-1728B52AA6E4}">
+                <adec:decorative xmlns:adec="http://schemas.microsoft.com/office/drawing/2017/decorative" val="1"/>
+              </a:ext>
+            </a:extLst>
+          </p:cNvPr>
+          <p:cNvSpPr>
+            <a:spLocks noGrp="1" noRot="1" noChangeAspect="1" noMove="1" noResize="1" noEditPoints="1" noAdjustHandles="1" noChangeArrowheads="1" noChangeShapeType="1" noTextEdit="1"/>
+          </p:cNvSpPr>
+          <p:nvPr>
+            <p:extLst>
+              <p:ext uri="{386F3935-93C4-4BCD-93E2-E3B085C9AB24}">
+                <p16:designElem xmlns:p16="http://schemas.microsoft.com/office/powerpoint/2015/main" val="1"/>
+              </p:ext>
+            </p:extLst>
+          </p:nvPr>
+        </p:nvSpPr>
+        <p:spPr>
+          <a:xfrm rot="10800000">
+            <a:off x="-2585" y="5288433"/>
+            <a:ext cx="9149779" cy="1591311"/>
+          </a:xfrm>
+          <a:prstGeom prst="rect">
+            <a:avLst/>
+          </a:prstGeom>
+          <a:gradFill flip="none" rotWithShape="1">
+            <a:gsLst>
+              <a:gs pos="0">
+                <a:schemeClr val="accent2"/>
+              </a:gs>
+              <a:gs pos="49000">
+                <a:schemeClr val="accent2">
+                  <a:alpha val="0"/>
+                </a:schemeClr>
+              </a:gs>
+            </a:gsLst>
+            <a:lin ang="5880000" scaled="0"/>
+            <a:tileRect/>
+          </a:gradFill>
+          <a:ln w="12700" cap="flat" cmpd="sng" algn="ctr">
+            <a:noFill/>
+            <a:prstDash val="solid"/>
+            <a:miter lim="800000"/>
+          </a:ln>
+          <a:effectLst/>
+        </p:spPr>
+        <p:style>
+          <a:lnRef idx="2">
+            <a:schemeClr val="accent1">
+              <a:shade val="50000"/>
+            </a:schemeClr>
+          </a:lnRef>
+          <a:fillRef idx="1">
+            <a:schemeClr val="accent1"/>
+          </a:fillRef>
+          <a:effectRef idx="0">
+            <a:schemeClr val="accent1"/>
+          </a:effectRef>
+          <a:fontRef idx="minor">
+            <a:schemeClr val="lt1"/>
+          </a:fontRef>
+        </p:style>
+        <p:txBody>
+          <a:bodyPr rtlCol="0" anchor="ctr"/>
+          <a:lstStyle/>
+          <a:p>
+            <a:pPr algn="r"/>
+            <a:endParaRPr lang="en-US"/>
+          </a:p>
+        </p:txBody>
+      </p:sp>
+      <p:sp>
+        <p:nvSpPr>
+          <p:cNvPr id="26" name="Rectangle 25">
+            <a:extLst>
+              <a:ext uri="{FF2B5EF4-FFF2-40B4-BE49-F238E27FC236}">
+                <a16:creationId xmlns:a16="http://schemas.microsoft.com/office/drawing/2014/main" id="{B6924B03-77BD-EAE3-2854-43363FF8E6BB}"/>
+              </a:ext>
+              <a:ext uri="{C183D7F6-B498-43B3-948B-1728B52AA6E4}">
+                <adec:decorative xmlns:adec="http://schemas.microsoft.com/office/drawing/2017/decorative" val="1"/>
+              </a:ext>
+            </a:extLst>
+          </p:cNvPr>
+          <p:cNvSpPr>
+            <a:spLocks noGrp="1" noRot="1" noChangeAspect="1" noMove="1" noResize="1" noEditPoints="1" noAdjustHandles="1" noChangeArrowheads="1" noChangeShapeType="1" noTextEdit="1"/>
+          </p:cNvSpPr>
+          <p:nvPr>
+            <p:extLst>
+              <p:ext uri="{386F3935-93C4-4BCD-93E2-E3B085C9AB24}">
+                <p16:designElem xmlns:p16="http://schemas.microsoft.com/office/powerpoint/2015/main" val="1"/>
+              </p:ext>
+            </p:extLst>
+          </p:nvPr>
+        </p:nvSpPr>
+        <p:spPr>
+          <a:xfrm rot="5400000">
+            <a:off x="105100" y="2905286"/>
+            <a:ext cx="3866773" cy="4082144"/>
+          </a:xfrm>
+          <a:prstGeom prst="rect">
+            <a:avLst/>
+          </a:prstGeom>
+          <a:gradFill flip="none" rotWithShape="1">
+            <a:gsLst>
+              <a:gs pos="0">
+                <a:schemeClr val="accent5"/>
+              </a:gs>
+              <a:gs pos="54000">
+                <a:schemeClr val="accent5">
+                  <a:lumMod val="60000"/>
+                  <a:lumOff val="40000"/>
+                  <a:alpha val="0"/>
+                </a:schemeClr>
+              </a:gs>
+            </a:gsLst>
+            <a:path path="circle">
+              <a:fillToRect l="100000" t="100000"/>
+            </a:path>
+            <a:tileRect r="-100000" b="-100000"/>
+          </a:gradFill>
+          <a:ln>
+            <a:noFill/>
+          </a:ln>
+        </p:spPr>
+        <p:style>
+          <a:lnRef idx="2">
+            <a:schemeClr val="accent1">
+              <a:shade val="50000"/>
+            </a:schemeClr>
+          </a:lnRef>
+          <a:fillRef idx="1">
+            <a:schemeClr val="accent1"/>
+          </a:fillRef>
+          <a:effectRef idx="0">
+            <a:schemeClr val="accent1"/>
+          </a:effectRef>
+          <a:fontRef idx="minor">
+            <a:schemeClr val="lt1"/>
+          </a:fontRef>
+        </p:style>
+        <p:txBody>
+          <a:bodyPr rtlCol="0" anchor="ctr"/>
+          <a:lstStyle/>
+          <a:p>
+            <a:pPr algn="ctr"/>
+            <a:endParaRPr lang="en-US"/>
+          </a:p>
+        </p:txBody>
+      </p:sp>
+      <p:sp>
+        <p:nvSpPr>
+          <p:cNvPr id="2" name="TextBox 1"/>
+          <p:cNvSpPr txBox="1"/>
+          <p:nvPr/>
+        </p:nvSpPr>
+        <p:spPr>
+          <a:xfrm>
+            <a:off x="644271" y="4121944"/>
+            <a:ext cx="5945838" cy="1620665"/>
+          </a:xfrm>
+          <a:prstGeom prst="rect">
+            <a:avLst/>
+          </a:prstGeom>
+        </p:spPr>
+        <p:txBody>
+          <a:bodyPr vert="horz" lIns="91440" tIns="45720" rIns="91440" bIns="45720" rtlCol="0" anchor="b">
+            <a:normAutofit/>
           </a:bodyPr>
           <a:lstStyle/>
           <a:p>
-            <a:pPr algn="ctr">
+            <a:pPr defTabSz="914400">
+              <a:lnSpc>
+                <a:spcPct val="90000"/>
+              </a:lnSpc>
+              <a:spcBef>
+                <a:spcPct val="0"/>
+              </a:spcBef>
+              <a:spcAft>
+                <a:spcPts val="600"/>
+              </a:spcAft>
+              <a:defRPr sz="5400" b="1">
+                <a:solidFill>
+                  <a:srgbClr val="FFFFFF"/>
+                </a:solidFill>
+              </a:defRPr>
+            </a:pPr>
+            <a:r>
+              <a:rPr lang="en-US" sz="3500" dirty="0">
+                <a:solidFill>
+                  <a:srgbClr val="FFFFFF"/>
+                </a:solidFill>
+                <a:latin typeface="+mj-lt"/>
+                <a:ea typeface="+mj-ea"/>
+                <a:cs typeface="+mj-cs"/>
+              </a:rPr>
+              <a:t>INVENTORY MANAGEMENT SYSTEM</a:t>
+            </a:r>
+          </a:p>
+        </p:txBody>
+      </p:sp>
+      <p:sp>
+        <p:nvSpPr>
+          <p:cNvPr id="3" name="TextBox 2"/>
+          <p:cNvSpPr txBox="1"/>
+          <p:nvPr/>
+        </p:nvSpPr>
+        <p:spPr>
+          <a:xfrm>
+            <a:off x="644271" y="5737867"/>
+            <a:ext cx="5956785" cy="618479"/>
+          </a:xfrm>
+          <a:prstGeom prst="rect">
+            <a:avLst/>
+          </a:prstGeom>
+        </p:spPr>
+        <p:txBody>
+          <a:bodyPr vert="horz" lIns="91440" tIns="45720" rIns="91440" bIns="45720" rtlCol="0">
+            <a:normAutofit/>
+          </a:bodyPr>
+          <a:lstStyle/>
+          <a:p>
+            <a:pPr defTabSz="914400">
+              <a:lnSpc>
+                <a:spcPct val="90000"/>
+              </a:lnSpc>
+              <a:spcBef>
+                <a:spcPts val="1000"/>
+              </a:spcBef>
               <a:defRPr sz="2800">
                 <a:solidFill>
                   <a:srgbClr val="C00000"/>
@@ -3177,6 +3615,11 @@
               </a:defRPr>
             </a:pPr>
             <a:r>
+              <a:rPr lang="en-US" sz="1700">
+                <a:solidFill>
+                  <a:srgbClr val="FFFFFF"/>
+                </a:solidFill>
+              </a:rPr>
               <a:t>Enterprise-Grade Stock Management Solution</a:t>
             </a:r>
           </a:p>
@@ -3191,7 +3634,7 @@
 </file>
 
 <file path=ppt/slides/slide10.xml><?xml version="1.0" encoding="utf-8"?>
-<p:sld xmlns:a="http://schemas.openxmlformats.org/drawingml/2006/main" xmlns:p="http://schemas.openxmlformats.org/presentationml/2006/main" xmlns:r="http://schemas.openxmlformats.org/officeDocument/2006/relationships">
+<p:sld xmlns:a="http://schemas.openxmlformats.org/drawingml/2006/main" xmlns:r="http://schemas.openxmlformats.org/officeDocument/2006/relationships" xmlns:p="http://schemas.openxmlformats.org/presentationml/2006/main">
   <p:cSld>
     <p:spTree>
       <p:nvGrpSpPr>
@@ -3199,7 +3642,14 @@
         <p:cNvGrpSpPr/>
         <p:nvPr/>
       </p:nvGrpSpPr>
-      <p:grpSpPr/>
+      <p:grpSpPr>
+        <a:xfrm>
+          <a:off x="0" y="0"/>
+          <a:ext cx="0" cy="0"/>
+          <a:chOff x="0" y="0"/>
+          <a:chExt cx="0" cy="0"/>
+        </a:xfrm>
+      </p:grpSpPr>
       <p:sp>
         <p:nvSpPr>
           <p:cNvPr id="2" name="Rectangle 1"/>
@@ -3242,6 +3692,7 @@
           <a:lstStyle/>
           <a:p>
             <a:pPr algn="ctr"/>
+            <a:endParaRPr/>
           </a:p>
         </p:txBody>
       </p:sp>
@@ -3275,7 +3726,7 @@
               </a:defRPr>
             </a:pPr>
             <a:r>
-              <a:t>Frontend Architecture</a:t>
+              <a:t>Key System Features</a:t>
             </a:r>
           </a:p>
         </p:txBody>
@@ -3316,184 +3767,169 @@
               </a:defRPr>
             </a:pPr>
             <a:r>
-              <a:t>Core Pages &amp; Dashboards:</a:t>
-            </a:r>
-          </a:p>
-          <a:p>
-            <a:pPr>
-              <a:spcBef>
-                <a:spcPts val="600"/>
-              </a:spcBef>
-              <a:spcAft>
-                <a:spcPts val="600"/>
-              </a:spcAft>
-              <a:defRPr sz="1800">
-                <a:solidFill>
-                  <a:srgbClr val="333333"/>
-                </a:solidFill>
-              </a:defRPr>
-            </a:pPr>
-            <a:r>
-              <a:t>• Approval Dashboard (Supervisor/Finance)</a:t>
-            </a:r>
-          </a:p>
-          <a:p>
-            <a:pPr>
-              <a:spcBef>
-                <a:spcPts val="600"/>
-              </a:spcBef>
-              <a:spcAft>
-                <a:spcPts val="600"/>
-              </a:spcAft>
-              <a:defRPr sz="1800">
-                <a:solidFill>
-                  <a:srgbClr val="333333"/>
-                </a:solidFill>
-              </a:defRPr>
-            </a:pPr>
-            <a:r>
-              <a:t>• Main Dashboard</a:t>
-            </a:r>
-          </a:p>
-          <a:p>
-            <a:pPr>
-              <a:spcBef>
-                <a:spcPts val="600"/>
-              </a:spcBef>
-              <a:spcAft>
-                <a:spcPts val="600"/>
-              </a:spcAft>
-              <a:defRPr sz="1800">
-                <a:solidFill>
-                  <a:srgbClr val="333333"/>
-                </a:solidFill>
-              </a:defRPr>
-            </a:pPr>
-            <a:r>
-              <a:t>• Stock Issuance Management</a:t>
-            </a:r>
-          </a:p>
-          <a:p>
-            <a:pPr>
-              <a:spcBef>
-                <a:spcPts val="600"/>
-              </a:spcBef>
-              <a:spcAft>
-                <a:spcPts val="600"/>
-              </a:spcAft>
-              <a:defRPr sz="1800">
-                <a:solidFill>
-                  <a:srgbClr val="333333"/>
-                </a:solidFill>
-              </a:defRPr>
-            </a:pPr>
-            <a:r>
-              <a:t>• Current Inventory Stock View</a:t>
-            </a:r>
-          </a:p>
-          <a:p>
-            <a:pPr>
-              <a:spcBef>
-                <a:spcPts val="600"/>
-              </a:spcBef>
-              <a:spcAft>
-                <a:spcPts val="600"/>
-              </a:spcAft>
-              <a:defRPr sz="1800">
-                <a:solidFill>
-                  <a:srgbClr val="333333"/>
-                </a:solidFill>
-              </a:defRPr>
-            </a:pPr>
-            <a:r>
-              <a:t>• Tender Creation &amp; Management</a:t>
-            </a:r>
-          </a:p>
-          <a:p>
-            <a:pPr>
-              <a:spcBef>
-                <a:spcPts val="600"/>
-              </a:spcBef>
-              <a:spcAft>
-                <a:spcPts val="600"/>
-              </a:spcAft>
-              <a:defRPr sz="1800">
-                <a:solidFill>
-                  <a:srgbClr val="333333"/>
-                </a:solidFill>
-              </a:defRPr>
-            </a:pPr>
-            <a:r>
-              <a:t>• Store Keeper Verification</a:t>
-            </a:r>
-          </a:p>
-          <a:p>
-            <a:pPr>
-              <a:spcBef>
-                <a:spcPts val="600"/>
-              </a:spcBef>
-              <a:spcAft>
-                <a:spcPts val="600"/>
-              </a:spcAft>
-              <a:defRPr sz="1800">
-                <a:solidFill>
-                  <a:srgbClr val="333333"/>
-                </a:solidFill>
-              </a:defRPr>
-            </a:pPr>
-            <a:r>
-              <a:t>• User Role Assignment</a:t>
-            </a:r>
-          </a:p>
-          <a:p>
-            <a:pPr>
-              <a:spcBef>
-                <a:spcPts val="600"/>
-              </a:spcBef>
-              <a:spcAft>
-                <a:spcPts val="600"/>
-              </a:spcAft>
-              <a:defRPr sz="1800">
-                <a:solidFill>
-                  <a:srgbClr val="333333"/>
-                </a:solidFill>
-              </a:defRPr>
-            </a:pPr>
-            <a:r>
-              <a:t>• Purchase Order Dashboard</a:t>
-            </a:r>
-          </a:p>
-          <a:p>
-            <a:pPr>
-              <a:spcBef>
-                <a:spcPts val="600"/>
-              </a:spcBef>
-              <a:spcAft>
-                <a:spcPts val="600"/>
-              </a:spcAft>
-              <a:defRPr sz="1800">
-                <a:solidFill>
-                  <a:srgbClr val="333333"/>
-                </a:solidFill>
-              </a:defRPr>
-            </a:pPr>
-          </a:p>
-          <a:p>
-            <a:pPr>
-              <a:spcBef>
-                <a:spcPts val="600"/>
-              </a:spcBef>
-              <a:spcAft>
-                <a:spcPts val="600"/>
-              </a:spcAft>
-              <a:defRPr sz="1800">
-                <a:solidFill>
-                  <a:srgbClr val="333333"/>
-                </a:solidFill>
-              </a:defRPr>
-            </a:pPr>
-            <a:r>
-              <a:t>Component Library: 25+ Reusable UI Components</a:t>
+              <a:t>✅ Real-time Stock Tracking</a:t>
+            </a:r>
+          </a:p>
+          <a:p>
+            <a:pPr>
+              <a:spcBef>
+                <a:spcPts val="600"/>
+              </a:spcBef>
+              <a:spcAft>
+                <a:spcPts val="600"/>
+              </a:spcAft>
+              <a:defRPr sz="1800">
+                <a:solidFill>
+                  <a:srgbClr val="333333"/>
+                </a:solidFill>
+              </a:defRPr>
+            </a:pPr>
+            <a:r>
+              <a:t>✅ Multi-Step Hierarchical Approval Workflows</a:t>
+            </a:r>
+          </a:p>
+          <a:p>
+            <a:pPr>
+              <a:spcBef>
+                <a:spcPts val="600"/>
+              </a:spcBef>
+              <a:spcAft>
+                <a:spcPts val="600"/>
+              </a:spcAft>
+              <a:defRPr sz="1800">
+                <a:solidFill>
+                  <a:srgbClr val="333333"/>
+                </a:solidFill>
+              </a:defRPr>
+            </a:pPr>
+            <a:r>
+              <a:t>✅ Complete Audit Trail &amp; History</a:t>
+            </a:r>
+          </a:p>
+          <a:p>
+            <a:pPr>
+              <a:spcBef>
+                <a:spcPts val="600"/>
+              </a:spcBef>
+              <a:spcAft>
+                <a:spcPts val="600"/>
+              </a:spcAft>
+              <a:defRPr sz="1800">
+                <a:solidFill>
+                  <a:srgbClr val="333333"/>
+                </a:solidFill>
+              </a:defRPr>
+            </a:pPr>
+            <a:r>
+              <a:t>✅ Role-Based Access Control (RBAC)</a:t>
+            </a:r>
+          </a:p>
+          <a:p>
+            <a:pPr>
+              <a:spcBef>
+                <a:spcPts val="600"/>
+              </a:spcBef>
+              <a:spcAft>
+                <a:spcPts val="600"/>
+              </a:spcAft>
+              <a:defRPr sz="1800">
+                <a:solidFill>
+                  <a:srgbClr val="333333"/>
+                </a:solidFill>
+              </a:defRPr>
+            </a:pPr>
+            <a:r>
+              <a:t>✅ Three-Level Inventory Management</a:t>
+            </a:r>
+          </a:p>
+          <a:p>
+            <a:pPr>
+              <a:spcBef>
+                <a:spcPts val="600"/>
+              </a:spcBef>
+              <a:spcAft>
+                <a:spcPts val="600"/>
+              </a:spcAft>
+              <a:defRPr sz="1800">
+                <a:solidFill>
+                  <a:srgbClr val="333333"/>
+                </a:solidFill>
+              </a:defRPr>
+            </a:pPr>
+            <a:r>
+              <a:t>✅ Multiple Tender Types Support</a:t>
+            </a:r>
+          </a:p>
+          <a:p>
+            <a:pPr>
+              <a:spcBef>
+                <a:spcPts val="600"/>
+              </a:spcBef>
+              <a:spcAft>
+                <a:spcPts val="600"/>
+              </a:spcAft>
+              <a:defRPr sz="1800">
+                <a:solidFill>
+                  <a:srgbClr val="333333"/>
+                </a:solidFill>
+              </a:defRPr>
+            </a:pPr>
+            <a:r>
+              <a:t>✅ Digital Annual Framework Contracts</a:t>
+            </a:r>
+          </a:p>
+          <a:p>
+            <a:pPr>
+              <a:spcBef>
+                <a:spcPts val="600"/>
+              </a:spcBef>
+              <a:spcAft>
+                <a:spcPts val="600"/>
+              </a:spcAft>
+              <a:defRPr sz="1800">
+                <a:solidFill>
+                  <a:srgbClr val="333333"/>
+                </a:solidFill>
+              </a:defRPr>
+            </a:pPr>
+            <a:r>
+              <a:t>✅ Serial Number &amp; Equipment Tracking</a:t>
+            </a:r>
+          </a:p>
+          <a:p>
+            <a:pPr>
+              <a:spcBef>
+                <a:spcPts val="600"/>
+              </a:spcBef>
+              <a:spcAft>
+                <a:spcPts val="600"/>
+              </a:spcAft>
+              <a:defRPr sz="1800">
+                <a:solidFill>
+                  <a:srgbClr val="333333"/>
+                </a:solidFill>
+              </a:defRPr>
+            </a:pPr>
+            <a:r>
+              <a:t>✅ Document Upload &amp; Attachment Support</a:t>
+            </a:r>
+          </a:p>
+          <a:p>
+            <a:pPr>
+              <a:spcBef>
+                <a:spcPts val="600"/>
+              </a:spcBef>
+              <a:spcAft>
+                <a:spcPts val="600"/>
+              </a:spcAft>
+              <a:defRPr sz="1800">
+                <a:solidFill>
+                  <a:srgbClr val="333333"/>
+                </a:solidFill>
+              </a:defRPr>
+            </a:pPr>
+            <a:r>
+              <a:t>✅ Soft Delete with Data Recovery</a:t>
             </a:r>
           </a:p>
         </p:txBody>
@@ -3507,7 +3943,7 @@
 </file>
 
 <file path=ppt/slides/slide11.xml><?xml version="1.0" encoding="utf-8"?>
-<p:sld xmlns:a="http://schemas.openxmlformats.org/drawingml/2006/main" xmlns:p="http://schemas.openxmlformats.org/presentationml/2006/main" xmlns:r="http://schemas.openxmlformats.org/officeDocument/2006/relationships">
+<p:sld xmlns:a="http://schemas.openxmlformats.org/drawingml/2006/main" xmlns:r="http://schemas.openxmlformats.org/officeDocument/2006/relationships" xmlns:p="http://schemas.openxmlformats.org/presentationml/2006/main">
   <p:cSld>
     <p:spTree>
       <p:nvGrpSpPr>
@@ -3515,7 +3951,14 @@
         <p:cNvGrpSpPr/>
         <p:nvPr/>
       </p:nvGrpSpPr>
-      <p:grpSpPr/>
+      <p:grpSpPr>
+        <a:xfrm>
+          <a:off x="0" y="0"/>
+          <a:ext cx="0" cy="0"/>
+          <a:chOff x="0" y="0"/>
+          <a:chExt cx="0" cy="0"/>
+        </a:xfrm>
+      </p:grpSpPr>
       <p:sp>
         <p:nvSpPr>
           <p:cNvPr id="2" name="Rectangle 1"/>
@@ -3558,6 +4001,7 @@
           <a:lstStyle/>
           <a:p>
             <a:pPr algn="ctr"/>
+            <a:endParaRPr/>
           </a:p>
         </p:txBody>
       </p:sp>
@@ -3591,7 +4035,7 @@
               </a:defRPr>
             </a:pPr>
             <a:r>
-              <a:t>Backend Architecture</a:t>
+              <a:t>Frontend Architecture</a:t>
             </a:r>
           </a:p>
         </p:txBody>
@@ -3632,220 +4076,185 @@
               </a:defRPr>
             </a:pPr>
             <a:r>
-              <a:t>API Server (Express.js):</a:t>
-            </a:r>
-          </a:p>
-          <a:p>
-            <a:pPr>
-              <a:spcBef>
-                <a:spcPts val="600"/>
-              </a:spcBef>
-              <a:spcAft>
-                <a:spcPts val="600"/>
-              </a:spcAft>
-              <a:defRPr sz="1800">
-                <a:solidFill>
-                  <a:srgbClr val="333333"/>
-                </a:solidFill>
-              </a:defRPr>
-            </a:pPr>
-            <a:r>
-              <a:t>• 40+ REST Endpoints</a:t>
-            </a:r>
-          </a:p>
-          <a:p>
-            <a:pPr>
-              <a:spcBef>
-                <a:spcPts val="600"/>
-              </a:spcBef>
-              <a:spcAft>
-                <a:spcPts val="600"/>
-              </a:spcAft>
-              <a:defRPr sz="1800">
-                <a:solidFill>
-                  <a:srgbClr val="333333"/>
-                </a:solidFill>
-              </a:defRPr>
-            </a:pPr>
-            <a:r>
-              <a:t>• Authentication &amp; Authorization Middleware</a:t>
-            </a:r>
-          </a:p>
-          <a:p>
-            <a:pPr>
-              <a:spcBef>
-                <a:spcPts val="600"/>
-              </a:spcBef>
-              <a:spcAft>
-                <a:spcPts val="600"/>
-              </a:spcAft>
-              <a:defRPr sz="1800">
-                <a:solidFill>
-                  <a:srgbClr val="333333"/>
-                </a:solidFill>
-              </a:defRPr>
-            </a:pPr>
-            <a:r>
-              <a:t>• Comprehensive Logging (Winston)</a:t>
-            </a:r>
-          </a:p>
-          <a:p>
-            <a:pPr>
-              <a:spcBef>
-                <a:spcPts val="600"/>
-              </a:spcBef>
-              <a:spcAft>
-                <a:spcPts val="600"/>
-              </a:spcAft>
-              <a:defRPr sz="1800">
-                <a:solidFill>
-                  <a:srgbClr val="333333"/>
-                </a:solidFill>
-              </a:defRPr>
-            </a:pPr>
-            <a:r>
-              <a:t>• Error Handling &amp; Validation</a:t>
-            </a:r>
-          </a:p>
-          <a:p>
-            <a:pPr>
-              <a:spcBef>
-                <a:spcPts val="600"/>
-              </a:spcBef>
-              <a:spcAft>
-                <a:spcPts val="600"/>
-              </a:spcAft>
-              <a:defRPr sz="1800">
-                <a:solidFill>
-                  <a:srgbClr val="333333"/>
-                </a:solidFill>
-              </a:defRPr>
-            </a:pPr>
-          </a:p>
-          <a:p>
-            <a:pPr>
-              <a:spcBef>
-                <a:spcPts val="600"/>
-              </a:spcBef>
-              <a:spcAft>
-                <a:spcPts val="600"/>
-              </a:spcAft>
-              <a:defRPr sz="1800">
-                <a:solidFill>
-                  <a:srgbClr val="333333"/>
-                </a:solidFill>
-              </a:defRPr>
-            </a:pPr>
-            <a:r>
-              <a:t>Key API Routes:</a:t>
-            </a:r>
-          </a:p>
-          <a:p>
-            <a:pPr>
-              <a:spcBef>
-                <a:spcPts val="600"/>
-              </a:spcBef>
-              <a:spcAft>
-                <a:spcPts val="600"/>
-              </a:spcAft>
-              <a:defRPr sz="1800">
-                <a:solidFill>
-                  <a:srgbClr val="333333"/>
-                </a:solidFill>
-              </a:defRPr>
-            </a:pPr>
-            <a:r>
-              <a:t>• /api/tenders - Tender operations</a:t>
-            </a:r>
-          </a:p>
-          <a:p>
-            <a:pPr>
-              <a:spcBef>
-                <a:spcPts val="600"/>
-              </a:spcBef>
-              <a:spcAft>
-                <a:spcPts val="600"/>
-              </a:spcAft>
-              <a:defRPr sz="1800">
-                <a:solidFill>
-                  <a:srgbClr val="333333"/>
-                </a:solidFill>
-              </a:defRPr>
-            </a:pPr>
-            <a:r>
-              <a:t>• /api/stock-issuance - Issuance management</a:t>
-            </a:r>
-          </a:p>
-          <a:p>
-            <a:pPr>
-              <a:spcBef>
-                <a:spcPts val="600"/>
-              </a:spcBef>
-              <a:spcAft>
-                <a:spcPts val="600"/>
-              </a:spcAft>
-              <a:defRPr sz="1800">
-                <a:solidFill>
-                  <a:srgbClr val="333333"/>
-                </a:solidFill>
-              </a:defRPr>
-            </a:pPr>
-            <a:r>
-              <a:t>• /api/approvals - Approval workflows</a:t>
-            </a:r>
-          </a:p>
-          <a:p>
-            <a:pPr>
-              <a:spcBef>
-                <a:spcPts val="600"/>
-              </a:spcBef>
-              <a:spcAft>
-                <a:spcPts val="600"/>
-              </a:spcAft>
-              <a:defRPr sz="1800">
-                <a:solidFill>
-                  <a:srgbClr val="333333"/>
-                </a:solidFill>
-              </a:defRPr>
-            </a:pPr>
-            <a:r>
-              <a:t>• /api/inventory - Stock queries</a:t>
-            </a:r>
-          </a:p>
-          <a:p>
-            <a:pPr>
-              <a:spcBef>
-                <a:spcPts val="600"/>
-              </a:spcBef>
-              <a:spcAft>
-                <a:spcPts val="600"/>
-              </a:spcAft>
-              <a:defRPr sz="1800">
-                <a:solidFill>
-                  <a:srgbClr val="333333"/>
-                </a:solidFill>
-              </a:defRPr>
-            </a:pPr>
-            <a:r>
-              <a:t>• /api/purchase-orders - PO management</a:t>
-            </a:r>
-          </a:p>
-          <a:p>
-            <a:pPr>
-              <a:spcBef>
-                <a:spcPts val="600"/>
-              </a:spcBef>
-              <a:spcAft>
-                <a:spcPts val="600"/>
-              </a:spcAft>
-              <a:defRPr sz="1800">
-                <a:solidFill>
-                  <a:srgbClr val="333333"/>
-                </a:solidFill>
-              </a:defRPr>
-            </a:pPr>
-            <a:r>
-              <a:t>• /api/users - User management</a:t>
+              <a:t>Core Pages &amp; Dashboards:</a:t>
+            </a:r>
+          </a:p>
+          <a:p>
+            <a:pPr>
+              <a:spcBef>
+                <a:spcPts val="600"/>
+              </a:spcBef>
+              <a:spcAft>
+                <a:spcPts val="600"/>
+              </a:spcAft>
+              <a:defRPr sz="1800">
+                <a:solidFill>
+                  <a:srgbClr val="333333"/>
+                </a:solidFill>
+              </a:defRPr>
+            </a:pPr>
+            <a:r>
+              <a:t>• Approval Dashboard (Supervisor/Finance)</a:t>
+            </a:r>
+          </a:p>
+          <a:p>
+            <a:pPr>
+              <a:spcBef>
+                <a:spcPts val="600"/>
+              </a:spcBef>
+              <a:spcAft>
+                <a:spcPts val="600"/>
+              </a:spcAft>
+              <a:defRPr sz="1800">
+                <a:solidFill>
+                  <a:srgbClr val="333333"/>
+                </a:solidFill>
+              </a:defRPr>
+            </a:pPr>
+            <a:r>
+              <a:t>• Main Dashboard</a:t>
+            </a:r>
+          </a:p>
+          <a:p>
+            <a:pPr>
+              <a:spcBef>
+                <a:spcPts val="600"/>
+              </a:spcBef>
+              <a:spcAft>
+                <a:spcPts val="600"/>
+              </a:spcAft>
+              <a:defRPr sz="1800">
+                <a:solidFill>
+                  <a:srgbClr val="333333"/>
+                </a:solidFill>
+              </a:defRPr>
+            </a:pPr>
+            <a:r>
+              <a:t>• Stock Issuance Management</a:t>
+            </a:r>
+          </a:p>
+          <a:p>
+            <a:pPr>
+              <a:spcBef>
+                <a:spcPts val="600"/>
+              </a:spcBef>
+              <a:spcAft>
+                <a:spcPts val="600"/>
+              </a:spcAft>
+              <a:defRPr sz="1800">
+                <a:solidFill>
+                  <a:srgbClr val="333333"/>
+                </a:solidFill>
+              </a:defRPr>
+            </a:pPr>
+            <a:r>
+              <a:t>• Current Inventory Stock View</a:t>
+            </a:r>
+          </a:p>
+          <a:p>
+            <a:pPr>
+              <a:spcBef>
+                <a:spcPts val="600"/>
+              </a:spcBef>
+              <a:spcAft>
+                <a:spcPts val="600"/>
+              </a:spcAft>
+              <a:defRPr sz="1800">
+                <a:solidFill>
+                  <a:srgbClr val="333333"/>
+                </a:solidFill>
+              </a:defRPr>
+            </a:pPr>
+            <a:r>
+              <a:t>• Tender Creation &amp; Management</a:t>
+            </a:r>
+          </a:p>
+          <a:p>
+            <a:pPr>
+              <a:spcBef>
+                <a:spcPts val="600"/>
+              </a:spcBef>
+              <a:spcAft>
+                <a:spcPts val="600"/>
+              </a:spcAft>
+              <a:defRPr sz="1800">
+                <a:solidFill>
+                  <a:srgbClr val="333333"/>
+                </a:solidFill>
+              </a:defRPr>
+            </a:pPr>
+            <a:r>
+              <a:t>• Store Keeper Verification</a:t>
+            </a:r>
+          </a:p>
+          <a:p>
+            <a:pPr>
+              <a:spcBef>
+                <a:spcPts val="600"/>
+              </a:spcBef>
+              <a:spcAft>
+                <a:spcPts val="600"/>
+              </a:spcAft>
+              <a:defRPr sz="1800">
+                <a:solidFill>
+                  <a:srgbClr val="333333"/>
+                </a:solidFill>
+              </a:defRPr>
+            </a:pPr>
+            <a:r>
+              <a:t>• User Role Assignment</a:t>
+            </a:r>
+          </a:p>
+          <a:p>
+            <a:pPr>
+              <a:spcBef>
+                <a:spcPts val="600"/>
+              </a:spcBef>
+              <a:spcAft>
+                <a:spcPts val="600"/>
+              </a:spcAft>
+              <a:defRPr sz="1800">
+                <a:solidFill>
+                  <a:srgbClr val="333333"/>
+                </a:solidFill>
+              </a:defRPr>
+            </a:pPr>
+            <a:r>
+              <a:t>• Purchase Order Dashboard</a:t>
+            </a:r>
+          </a:p>
+          <a:p>
+            <a:pPr>
+              <a:spcBef>
+                <a:spcPts val="600"/>
+              </a:spcBef>
+              <a:spcAft>
+                <a:spcPts val="600"/>
+              </a:spcAft>
+              <a:defRPr sz="1800">
+                <a:solidFill>
+                  <a:srgbClr val="333333"/>
+                </a:solidFill>
+              </a:defRPr>
+            </a:pPr>
+            <a:endParaRPr/>
+          </a:p>
+          <a:p>
+            <a:pPr>
+              <a:spcBef>
+                <a:spcPts val="600"/>
+              </a:spcBef>
+              <a:spcAft>
+                <a:spcPts val="600"/>
+              </a:spcAft>
+              <a:defRPr sz="1800">
+                <a:solidFill>
+                  <a:srgbClr val="333333"/>
+                </a:solidFill>
+              </a:defRPr>
+            </a:pPr>
+            <a:r>
+              <a:t>Component Library: 25+ Reusable UI Components</a:t>
             </a:r>
           </a:p>
         </p:txBody>
@@ -3859,7 +4268,7 @@
 </file>
 
 <file path=ppt/slides/slide12.xml><?xml version="1.0" encoding="utf-8"?>
-<p:sld xmlns:a="http://schemas.openxmlformats.org/drawingml/2006/main" xmlns:p="http://schemas.openxmlformats.org/presentationml/2006/main" xmlns:r="http://schemas.openxmlformats.org/officeDocument/2006/relationships">
+<p:sld xmlns:a="http://schemas.openxmlformats.org/drawingml/2006/main" xmlns:r="http://schemas.openxmlformats.org/officeDocument/2006/relationships" xmlns:p="http://schemas.openxmlformats.org/presentationml/2006/main">
   <p:cSld>
     <p:spTree>
       <p:nvGrpSpPr>
@@ -3867,7 +4276,375 @@
         <p:cNvGrpSpPr/>
         <p:nvPr/>
       </p:nvGrpSpPr>
-      <p:grpSpPr/>
+      <p:grpSpPr>
+        <a:xfrm>
+          <a:off x="0" y="0"/>
+          <a:ext cx="0" cy="0"/>
+          <a:chOff x="0" y="0"/>
+          <a:chExt cx="0" cy="0"/>
+        </a:xfrm>
+      </p:grpSpPr>
+      <p:sp>
+        <p:nvSpPr>
+          <p:cNvPr id="2" name="Rectangle 1"/>
+          <p:cNvSpPr/>
+          <p:nvPr/>
+        </p:nvSpPr>
+        <p:spPr>
+          <a:xfrm>
+            <a:off x="0" y="0"/>
+            <a:ext cx="9144000" cy="914400"/>
+          </a:xfrm>
+          <a:prstGeom prst="rect">
+            <a:avLst/>
+          </a:prstGeom>
+          <a:solidFill>
+            <a:srgbClr val="1F4E79"/>
+          </a:solidFill>
+          <a:ln>
+            <a:solidFill>
+              <a:srgbClr val="1F4E79"/>
+            </a:solidFill>
+          </a:ln>
+        </p:spPr>
+        <p:style>
+          <a:lnRef idx="1">
+            <a:schemeClr val="accent1"/>
+          </a:lnRef>
+          <a:fillRef idx="3">
+            <a:schemeClr val="accent1"/>
+          </a:fillRef>
+          <a:effectRef idx="2">
+            <a:schemeClr val="accent1"/>
+          </a:effectRef>
+          <a:fontRef idx="minor">
+            <a:schemeClr val="lt1"/>
+          </a:fontRef>
+        </p:style>
+        <p:txBody>
+          <a:bodyPr rtlCol="0" anchor="ctr"/>
+          <a:lstStyle/>
+          <a:p>
+            <a:pPr algn="ctr"/>
+            <a:endParaRPr/>
+          </a:p>
+        </p:txBody>
+      </p:sp>
+      <p:sp>
+        <p:nvSpPr>
+          <p:cNvPr id="3" name="TextBox 2"/>
+          <p:cNvSpPr txBox="1"/>
+          <p:nvPr/>
+        </p:nvSpPr>
+        <p:spPr>
+          <a:xfrm>
+            <a:off x="457200" y="182880"/>
+            <a:ext cx="8229600" cy="731520"/>
+          </a:xfrm>
+          <a:prstGeom prst="rect">
+            <a:avLst/>
+          </a:prstGeom>
+          <a:noFill/>
+        </p:spPr>
+        <p:txBody>
+          <a:bodyPr wrap="square">
+            <a:spAutoFit/>
+          </a:bodyPr>
+          <a:lstStyle/>
+          <a:p>
+            <a:pPr>
+              <a:defRPr sz="4000" b="1">
+                <a:solidFill>
+                  <a:srgbClr val="FFFFFF"/>
+                </a:solidFill>
+              </a:defRPr>
+            </a:pPr>
+            <a:r>
+              <a:t>Backend Architecture</a:t>
+            </a:r>
+          </a:p>
+        </p:txBody>
+      </p:sp>
+      <p:sp>
+        <p:nvSpPr>
+          <p:cNvPr id="4" name="TextBox 3"/>
+          <p:cNvSpPr txBox="1"/>
+          <p:nvPr/>
+        </p:nvSpPr>
+        <p:spPr>
+          <a:xfrm>
+            <a:off x="731520" y="1645920"/>
+            <a:ext cx="7680960" cy="4572000"/>
+          </a:xfrm>
+          <a:prstGeom prst="rect">
+            <a:avLst/>
+          </a:prstGeom>
+          <a:noFill/>
+        </p:spPr>
+        <p:txBody>
+          <a:bodyPr wrap="square">
+            <a:spAutoFit/>
+          </a:bodyPr>
+          <a:lstStyle/>
+          <a:p>
+            <a:pPr>
+              <a:spcBef>
+                <a:spcPts val="600"/>
+              </a:spcBef>
+              <a:spcAft>
+                <a:spcPts val="600"/>
+              </a:spcAft>
+              <a:defRPr sz="1800">
+                <a:solidFill>
+                  <a:srgbClr val="333333"/>
+                </a:solidFill>
+              </a:defRPr>
+            </a:pPr>
+            <a:r>
+              <a:t>API Server (Express.js):</a:t>
+            </a:r>
+          </a:p>
+          <a:p>
+            <a:pPr>
+              <a:spcBef>
+                <a:spcPts val="600"/>
+              </a:spcBef>
+              <a:spcAft>
+                <a:spcPts val="600"/>
+              </a:spcAft>
+              <a:defRPr sz="1800">
+                <a:solidFill>
+                  <a:srgbClr val="333333"/>
+                </a:solidFill>
+              </a:defRPr>
+            </a:pPr>
+            <a:r>
+              <a:t>• 40+ REST Endpoints</a:t>
+            </a:r>
+          </a:p>
+          <a:p>
+            <a:pPr>
+              <a:spcBef>
+                <a:spcPts val="600"/>
+              </a:spcBef>
+              <a:spcAft>
+                <a:spcPts val="600"/>
+              </a:spcAft>
+              <a:defRPr sz="1800">
+                <a:solidFill>
+                  <a:srgbClr val="333333"/>
+                </a:solidFill>
+              </a:defRPr>
+            </a:pPr>
+            <a:r>
+              <a:t>• Authentication &amp; Authorization Middleware</a:t>
+            </a:r>
+          </a:p>
+          <a:p>
+            <a:pPr>
+              <a:spcBef>
+                <a:spcPts val="600"/>
+              </a:spcBef>
+              <a:spcAft>
+                <a:spcPts val="600"/>
+              </a:spcAft>
+              <a:defRPr sz="1800">
+                <a:solidFill>
+                  <a:srgbClr val="333333"/>
+                </a:solidFill>
+              </a:defRPr>
+            </a:pPr>
+            <a:r>
+              <a:t>• Comprehensive Logging (Winston)</a:t>
+            </a:r>
+          </a:p>
+          <a:p>
+            <a:pPr>
+              <a:spcBef>
+                <a:spcPts val="600"/>
+              </a:spcBef>
+              <a:spcAft>
+                <a:spcPts val="600"/>
+              </a:spcAft>
+              <a:defRPr sz="1800">
+                <a:solidFill>
+                  <a:srgbClr val="333333"/>
+                </a:solidFill>
+              </a:defRPr>
+            </a:pPr>
+            <a:r>
+              <a:t>• Error Handling &amp; Validation</a:t>
+            </a:r>
+          </a:p>
+          <a:p>
+            <a:pPr>
+              <a:spcBef>
+                <a:spcPts val="600"/>
+              </a:spcBef>
+              <a:spcAft>
+                <a:spcPts val="600"/>
+              </a:spcAft>
+              <a:defRPr sz="1800">
+                <a:solidFill>
+                  <a:srgbClr val="333333"/>
+                </a:solidFill>
+              </a:defRPr>
+            </a:pPr>
+            <a:endParaRPr/>
+          </a:p>
+          <a:p>
+            <a:pPr>
+              <a:spcBef>
+                <a:spcPts val="600"/>
+              </a:spcBef>
+              <a:spcAft>
+                <a:spcPts val="600"/>
+              </a:spcAft>
+              <a:defRPr sz="1800">
+                <a:solidFill>
+                  <a:srgbClr val="333333"/>
+                </a:solidFill>
+              </a:defRPr>
+            </a:pPr>
+            <a:r>
+              <a:t>Key API Routes:</a:t>
+            </a:r>
+          </a:p>
+          <a:p>
+            <a:pPr>
+              <a:spcBef>
+                <a:spcPts val="600"/>
+              </a:spcBef>
+              <a:spcAft>
+                <a:spcPts val="600"/>
+              </a:spcAft>
+              <a:defRPr sz="1800">
+                <a:solidFill>
+                  <a:srgbClr val="333333"/>
+                </a:solidFill>
+              </a:defRPr>
+            </a:pPr>
+            <a:r>
+              <a:t>• /api/tenders - Tender operations</a:t>
+            </a:r>
+          </a:p>
+          <a:p>
+            <a:pPr>
+              <a:spcBef>
+                <a:spcPts val="600"/>
+              </a:spcBef>
+              <a:spcAft>
+                <a:spcPts val="600"/>
+              </a:spcAft>
+              <a:defRPr sz="1800">
+                <a:solidFill>
+                  <a:srgbClr val="333333"/>
+                </a:solidFill>
+              </a:defRPr>
+            </a:pPr>
+            <a:r>
+              <a:t>• /api/stock-issuance - Issuance management</a:t>
+            </a:r>
+          </a:p>
+          <a:p>
+            <a:pPr>
+              <a:spcBef>
+                <a:spcPts val="600"/>
+              </a:spcBef>
+              <a:spcAft>
+                <a:spcPts val="600"/>
+              </a:spcAft>
+              <a:defRPr sz="1800">
+                <a:solidFill>
+                  <a:srgbClr val="333333"/>
+                </a:solidFill>
+              </a:defRPr>
+            </a:pPr>
+            <a:r>
+              <a:t>• /api/approvals - Approval workflows</a:t>
+            </a:r>
+          </a:p>
+          <a:p>
+            <a:pPr>
+              <a:spcBef>
+                <a:spcPts val="600"/>
+              </a:spcBef>
+              <a:spcAft>
+                <a:spcPts val="600"/>
+              </a:spcAft>
+              <a:defRPr sz="1800">
+                <a:solidFill>
+                  <a:srgbClr val="333333"/>
+                </a:solidFill>
+              </a:defRPr>
+            </a:pPr>
+            <a:r>
+              <a:t>• /api/inventory - Stock queries</a:t>
+            </a:r>
+          </a:p>
+          <a:p>
+            <a:pPr>
+              <a:spcBef>
+                <a:spcPts val="600"/>
+              </a:spcBef>
+              <a:spcAft>
+                <a:spcPts val="600"/>
+              </a:spcAft>
+              <a:defRPr sz="1800">
+                <a:solidFill>
+                  <a:srgbClr val="333333"/>
+                </a:solidFill>
+              </a:defRPr>
+            </a:pPr>
+            <a:r>
+              <a:t>• /api/purchase-orders - PO management</a:t>
+            </a:r>
+          </a:p>
+          <a:p>
+            <a:pPr>
+              <a:spcBef>
+                <a:spcPts val="600"/>
+              </a:spcBef>
+              <a:spcAft>
+                <a:spcPts val="600"/>
+              </a:spcAft>
+              <a:defRPr sz="1800">
+                <a:solidFill>
+                  <a:srgbClr val="333333"/>
+                </a:solidFill>
+              </a:defRPr>
+            </a:pPr>
+            <a:r>
+              <a:t>• /api/users - User management</a:t>
+            </a:r>
+          </a:p>
+        </p:txBody>
+      </p:sp>
+    </p:spTree>
+  </p:cSld>
+  <p:clrMapOvr>
+    <a:masterClrMapping/>
+  </p:clrMapOvr>
+</p:sld>
+</file>
+
+<file path=ppt/slides/slide13.xml><?xml version="1.0" encoding="utf-8"?>
+<p:sld xmlns:a="http://schemas.openxmlformats.org/drawingml/2006/main" xmlns:r="http://schemas.openxmlformats.org/officeDocument/2006/relationships" xmlns:p="http://schemas.openxmlformats.org/presentationml/2006/main">
+  <p:cSld>
+    <p:spTree>
+      <p:nvGrpSpPr>
+        <p:cNvPr id="1" name=""/>
+        <p:cNvGrpSpPr/>
+        <p:nvPr/>
+      </p:nvGrpSpPr>
+      <p:grpSpPr>
+        <a:xfrm>
+          <a:off x="0" y="0"/>
+          <a:ext cx="0" cy="0"/>
+          <a:chOff x="0" y="0"/>
+          <a:chExt cx="0" cy="0"/>
+        </a:xfrm>
+      </p:grpSpPr>
       <p:sp>
         <p:nvSpPr>
           <p:cNvPr id="2" name="Rectangle 1"/>
@@ -3910,6 +4687,7 @@
           <a:lstStyle/>
           <a:p>
             <a:pPr algn="ctr"/>
+            <a:endParaRPr/>
           </a:p>
         </p:txBody>
       </p:sp>
@@ -4204,6 +4982,7 @@
                 </a:solidFill>
               </a:defRPr>
             </a:pPr>
+            <a:endParaRPr/>
           </a:p>
           <a:p>
             <a:pPr>
@@ -4305,8 +5084,8 @@
 </p:sld>
 </file>
 
-<file path=ppt/slides/slide13.xml><?xml version="1.0" encoding="utf-8"?>
-<p:sld xmlns:a="http://schemas.openxmlformats.org/drawingml/2006/main" xmlns:p="http://schemas.openxmlformats.org/presentationml/2006/main" xmlns:r="http://schemas.openxmlformats.org/officeDocument/2006/relationships">
+<file path=ppt/slides/slide14.xml><?xml version="1.0" encoding="utf-8"?>
+<p:sld xmlns:a="http://schemas.openxmlformats.org/drawingml/2006/main" xmlns:r="http://schemas.openxmlformats.org/officeDocument/2006/relationships" xmlns:p="http://schemas.openxmlformats.org/presentationml/2006/main">
   <p:cSld>
     <p:spTree>
       <p:nvGrpSpPr>
@@ -4314,7 +5093,14 @@
         <p:cNvGrpSpPr/>
         <p:nvPr/>
       </p:nvGrpSpPr>
-      <p:grpSpPr/>
+      <p:grpSpPr>
+        <a:xfrm>
+          <a:off x="0" y="0"/>
+          <a:ext cx="0" cy="0"/>
+          <a:chOff x="0" y="0"/>
+          <a:chExt cx="0" cy="0"/>
+        </a:xfrm>
+      </p:grpSpPr>
       <p:sp>
         <p:nvSpPr>
           <p:cNvPr id="2" name="Rectangle 1"/>
@@ -4357,6 +5143,7 @@
           <a:lstStyle/>
           <a:p>
             <a:pPr algn="ctr"/>
+            <a:endParaRPr/>
           </a:p>
         </p:txBody>
       </p:sp>
@@ -4484,6 +5271,7 @@
                 </a:solidFill>
               </a:defRPr>
             </a:pPr>
+            <a:endParaRPr/>
           </a:p>
           <a:p>
             <a:pPr>
@@ -4571,6 +5359,7 @@
                 </a:solidFill>
               </a:defRPr>
             </a:pPr>
+            <a:endParaRPr/>
           </a:p>
           <a:p>
             <a:pPr>
@@ -4636,8 +5425,8 @@
 </p:sld>
 </file>
 
-<file path=ppt/slides/slide14.xml><?xml version="1.0" encoding="utf-8"?>
-<p:sld xmlns:a="http://schemas.openxmlformats.org/drawingml/2006/main" xmlns:p="http://schemas.openxmlformats.org/presentationml/2006/main" xmlns:r="http://schemas.openxmlformats.org/officeDocument/2006/relationships">
+<file path=ppt/slides/slide15.xml><?xml version="1.0" encoding="utf-8"?>
+<p:sld xmlns:a="http://schemas.openxmlformats.org/drawingml/2006/main" xmlns:r="http://schemas.openxmlformats.org/officeDocument/2006/relationships" xmlns:p="http://schemas.openxmlformats.org/presentationml/2006/main">
   <p:cSld>
     <p:spTree>
       <p:nvGrpSpPr>
@@ -4645,7 +5434,14 @@
         <p:cNvGrpSpPr/>
         <p:nvPr/>
       </p:nvGrpSpPr>
-      <p:grpSpPr/>
+      <p:grpSpPr>
+        <a:xfrm>
+          <a:off x="0" y="0"/>
+          <a:ext cx="0" cy="0"/>
+          <a:chOff x="0" y="0"/>
+          <a:chExt cx="0" cy="0"/>
+        </a:xfrm>
+      </p:grpSpPr>
       <p:sp>
         <p:nvSpPr>
           <p:cNvPr id="2" name="Rectangle 1"/>
@@ -4688,6 +5484,7 @@
           <a:lstStyle/>
           <a:p>
             <a:pPr algn="ctr"/>
+            <a:endParaRPr/>
           </a:p>
         </p:txBody>
       </p:sp>
@@ -4833,6 +5630,7 @@
                 </a:solidFill>
               </a:defRPr>
             </a:pPr>
+            <a:endParaRPr/>
           </a:p>
           <a:p>
             <a:pPr>
@@ -4934,8 +5732,8 @@
 </p:sld>
 </file>
 
-<file path=ppt/slides/slide15.xml><?xml version="1.0" encoding="utf-8"?>
-<p:sld xmlns:a="http://schemas.openxmlformats.org/drawingml/2006/main" xmlns:p="http://schemas.openxmlformats.org/presentationml/2006/main" xmlns:r="http://schemas.openxmlformats.org/officeDocument/2006/relationships">
+<file path=ppt/slides/slide16.xml><?xml version="1.0" encoding="utf-8"?>
+<p:sld xmlns:a="http://schemas.openxmlformats.org/drawingml/2006/main" xmlns:r="http://schemas.openxmlformats.org/officeDocument/2006/relationships" xmlns:p="http://schemas.openxmlformats.org/presentationml/2006/main">
   <p:cSld>
     <p:spTree>
       <p:nvGrpSpPr>
@@ -4943,7 +5741,14 @@
         <p:cNvGrpSpPr/>
         <p:nvPr/>
       </p:nvGrpSpPr>
-      <p:grpSpPr/>
+      <p:grpSpPr>
+        <a:xfrm>
+          <a:off x="0" y="0"/>
+          <a:ext cx="0" cy="0"/>
+          <a:chOff x="0" y="0"/>
+          <a:chExt cx="0" cy="0"/>
+        </a:xfrm>
+      </p:grpSpPr>
       <p:sp>
         <p:nvSpPr>
           <p:cNvPr id="2" name="Rectangle 1"/>
@@ -4986,6 +5791,7 @@
           <a:lstStyle/>
           <a:p>
             <a:pPr algn="ctr"/>
+            <a:endParaRPr/>
           </a:p>
         </p:txBody>
       </p:sp>
@@ -5113,6 +5919,7 @@
                 </a:solidFill>
               </a:defRPr>
             </a:pPr>
+            <a:endParaRPr/>
           </a:p>
           <a:p>
             <a:pPr>
@@ -5182,6 +5989,7 @@
                 </a:solidFill>
               </a:defRPr>
             </a:pPr>
+            <a:endParaRPr/>
           </a:p>
           <a:p>
             <a:pPr>
@@ -5265,8 +6073,8 @@
 </p:sld>
 </file>
 
-<file path=ppt/slides/slide16.xml><?xml version="1.0" encoding="utf-8"?>
-<p:sld xmlns:a="http://schemas.openxmlformats.org/drawingml/2006/main" xmlns:p="http://schemas.openxmlformats.org/presentationml/2006/main" xmlns:r="http://schemas.openxmlformats.org/officeDocument/2006/relationships">
+<file path=ppt/slides/slide17.xml><?xml version="1.0" encoding="utf-8"?>
+<p:sld xmlns:a="http://schemas.openxmlformats.org/drawingml/2006/main" xmlns:r="http://schemas.openxmlformats.org/officeDocument/2006/relationships" xmlns:p="http://schemas.openxmlformats.org/presentationml/2006/main">
   <p:cSld>
     <p:spTree>
       <p:nvGrpSpPr>
@@ -5274,7 +6082,14 @@
         <p:cNvGrpSpPr/>
         <p:nvPr/>
       </p:nvGrpSpPr>
-      <p:grpSpPr/>
+      <p:grpSpPr>
+        <a:xfrm>
+          <a:off x="0" y="0"/>
+          <a:ext cx="0" cy="0"/>
+          <a:chOff x="0" y="0"/>
+          <a:chExt cx="0" cy="0"/>
+        </a:xfrm>
+      </p:grpSpPr>
       <p:sp>
         <p:nvSpPr>
           <p:cNvPr id="2" name="Rectangle 1"/>
@@ -5317,6 +6132,7 @@
           <a:lstStyle/>
           <a:p>
             <a:pPr algn="ctr"/>
+            <a:endParaRPr/>
           </a:p>
         </p:txBody>
       </p:sp>
@@ -5548,8 +6364,8 @@
 </p:sld>
 </file>
 
-<file path=ppt/slides/slide17.xml><?xml version="1.0" encoding="utf-8"?>
-<p:sld xmlns:a="http://schemas.openxmlformats.org/drawingml/2006/main" xmlns:p="http://schemas.openxmlformats.org/presentationml/2006/main" xmlns:r="http://schemas.openxmlformats.org/officeDocument/2006/relationships">
+<file path=ppt/slides/slide18.xml><?xml version="1.0" encoding="utf-8"?>
+<p:sld xmlns:a="http://schemas.openxmlformats.org/drawingml/2006/main" xmlns:r="http://schemas.openxmlformats.org/officeDocument/2006/relationships" xmlns:p="http://schemas.openxmlformats.org/presentationml/2006/main">
   <p:cSld>
     <p:bg>
       <p:bgPr>
@@ -5565,7 +6381,14 @@
         <p:cNvGrpSpPr/>
         <p:nvPr/>
       </p:nvGrpSpPr>
-      <p:grpSpPr/>
+      <p:grpSpPr>
+        <a:xfrm>
+          <a:off x="0" y="0"/>
+          <a:ext cx="0" cy="0"/>
+          <a:chOff x="0" y="0"/>
+          <a:chExt cx="0" cy="0"/>
+        </a:xfrm>
+      </p:grpSpPr>
       <p:sp>
         <p:nvSpPr>
           <p:cNvPr id="2" name="TextBox 1"/>
@@ -5645,7 +6468,7 @@
 </file>
 
 <file path=ppt/slides/slide2.xml><?xml version="1.0" encoding="utf-8"?>
-<p:sld xmlns:a="http://schemas.openxmlformats.org/drawingml/2006/main" xmlns:p="http://schemas.openxmlformats.org/presentationml/2006/main" xmlns:r="http://schemas.openxmlformats.org/officeDocument/2006/relationships">
+<p:sld xmlns:a="http://schemas.openxmlformats.org/drawingml/2006/main" xmlns:r="http://schemas.openxmlformats.org/officeDocument/2006/relationships" xmlns:p="http://schemas.openxmlformats.org/presentationml/2006/main">
   <p:cSld>
     <p:spTree>
       <p:nvGrpSpPr>
@@ -5653,7 +6476,44 @@
         <p:cNvGrpSpPr/>
         <p:nvPr/>
       </p:nvGrpSpPr>
-      <p:grpSpPr/>
+      <p:grpSpPr>
+        <a:xfrm>
+          <a:off x="0" y="0"/>
+          <a:ext cx="0" cy="0"/>
+          <a:chOff x="0" y="0"/>
+          <a:chExt cx="0" cy="0"/>
+        </a:xfrm>
+      </p:grpSpPr>
+    </p:spTree>
+    <p:extLst>
+      <p:ext uri="{BB962C8B-B14F-4D97-AF65-F5344CB8AC3E}">
+        <p14:creationId xmlns:p14="http://schemas.microsoft.com/office/powerpoint/2010/main" val="2612933034"/>
+      </p:ext>
+    </p:extLst>
+  </p:cSld>
+  <p:clrMapOvr>
+    <a:masterClrMapping/>
+  </p:clrMapOvr>
+</p:sld>
+</file>
+
+<file path=ppt/slides/slide3.xml><?xml version="1.0" encoding="utf-8"?>
+<p:sld xmlns:a="http://schemas.openxmlformats.org/drawingml/2006/main" xmlns:r="http://schemas.openxmlformats.org/officeDocument/2006/relationships" xmlns:p="http://schemas.openxmlformats.org/presentationml/2006/main">
+  <p:cSld>
+    <p:spTree>
+      <p:nvGrpSpPr>
+        <p:cNvPr id="1" name=""/>
+        <p:cNvGrpSpPr/>
+        <p:nvPr/>
+      </p:nvGrpSpPr>
+      <p:grpSpPr>
+        <a:xfrm>
+          <a:off x="0" y="0"/>
+          <a:ext cx="0" cy="0"/>
+          <a:chOff x="0" y="0"/>
+          <a:chExt cx="0" cy="0"/>
+        </a:xfrm>
+      </p:grpSpPr>
       <p:sp>
         <p:nvSpPr>
           <p:cNvPr id="2" name="Rectangle 1"/>
@@ -5696,6 +6556,7 @@
           <a:lstStyle/>
           <a:p>
             <a:pPr algn="ctr"/>
+            <a:endParaRPr/>
           </a:p>
         </p:txBody>
       </p:sp>
@@ -5770,6 +6631,7 @@
               </a:defRPr>
             </a:pPr>
             <a:r>
+              <a:rPr dirty="0"/>
               <a:t>✓ Enterprise-grade web-based inventory platform</a:t>
             </a:r>
           </a:p>
@@ -5788,6 +6650,7 @@
               </a:defRPr>
             </a:pPr>
             <a:r>
+              <a:rPr dirty="0"/>
               <a:t>✓ Multi-location inventory management with hierarchical control</a:t>
             </a:r>
           </a:p>
@@ -5806,6 +6669,7 @@
               </a:defRPr>
             </a:pPr>
             <a:r>
+              <a:rPr dirty="0"/>
               <a:t>✓ Integrated procurement and stock issuance workflows</a:t>
             </a:r>
           </a:p>
@@ -5824,6 +6688,7 @@
               </a:defRPr>
             </a:pPr>
             <a:r>
+              <a:rPr dirty="0"/>
               <a:t>✓ Real-time inventory tracking and reconciliation</a:t>
             </a:r>
           </a:p>
@@ -5842,6 +6707,7 @@
               </a:defRPr>
             </a:pPr>
             <a:r>
+              <a:rPr dirty="0"/>
               <a:t>✓ Multi-level approval workflows with role-based access</a:t>
             </a:r>
           </a:p>
@@ -5860,6 +6726,7 @@
               </a:defRPr>
             </a:pPr>
             <a:r>
+              <a:rPr dirty="0"/>
               <a:t>✓ Production-ready system managing 15+ items across multiple locations</a:t>
             </a:r>
           </a:p>
@@ -5873,8 +6740,8 @@
 </p:sld>
 </file>
 
-<file path=ppt/slides/slide3.xml><?xml version="1.0" encoding="utf-8"?>
-<p:sld xmlns:a="http://schemas.openxmlformats.org/drawingml/2006/main" xmlns:p="http://schemas.openxmlformats.org/presentationml/2006/main" xmlns:r="http://schemas.openxmlformats.org/officeDocument/2006/relationships">
+<file path=ppt/slides/slide4.xml><?xml version="1.0" encoding="utf-8"?>
+<p:sld xmlns:a="http://schemas.openxmlformats.org/drawingml/2006/main" xmlns:r="http://schemas.openxmlformats.org/officeDocument/2006/relationships" xmlns:p="http://schemas.openxmlformats.org/presentationml/2006/main">
   <p:cSld>
     <p:spTree>
       <p:nvGrpSpPr>
@@ -5882,7 +6749,14 @@
         <p:cNvGrpSpPr/>
         <p:nvPr/>
       </p:nvGrpSpPr>
-      <p:grpSpPr/>
+      <p:grpSpPr>
+        <a:xfrm>
+          <a:off x="0" y="0"/>
+          <a:ext cx="0" cy="0"/>
+          <a:chOff x="0" y="0"/>
+          <a:chExt cx="0" cy="0"/>
+        </a:xfrm>
+      </p:grpSpPr>
       <p:sp>
         <p:nvSpPr>
           <p:cNvPr id="2" name="Rectangle 1"/>
@@ -5925,6 +6799,7 @@
           <a:lstStyle/>
           <a:p>
             <a:pPr algn="ctr"/>
+            <a:endParaRPr/>
           </a:p>
         </p:txBody>
       </p:sp>
@@ -6088,6 +6963,7 @@
                 </a:solidFill>
               </a:defRPr>
             </a:pPr>
+            <a:endParaRPr/>
           </a:p>
           <a:p>
             <a:pPr>
@@ -6270,6 +7146,7 @@
                 </a:solidFill>
               </a:defRPr>
             </a:pPr>
+            <a:endParaRPr/>
           </a:p>
           <a:p>
             <a:pPr>
@@ -6335,8 +7212,8 @@
 </p:sld>
 </file>
 
-<file path=ppt/slides/slide4.xml><?xml version="1.0" encoding="utf-8"?>
-<p:sld xmlns:a="http://schemas.openxmlformats.org/drawingml/2006/main" xmlns:p="http://schemas.openxmlformats.org/presentationml/2006/main" xmlns:r="http://schemas.openxmlformats.org/officeDocument/2006/relationships">
+<file path=ppt/slides/slide5.xml><?xml version="1.0" encoding="utf-8"?>
+<p:sld xmlns:a="http://schemas.openxmlformats.org/drawingml/2006/main" xmlns:r="http://schemas.openxmlformats.org/officeDocument/2006/relationships" xmlns:p="http://schemas.openxmlformats.org/presentationml/2006/main">
   <p:cSld>
     <p:spTree>
       <p:nvGrpSpPr>
@@ -6344,7 +7221,14 @@
         <p:cNvGrpSpPr/>
         <p:nvPr/>
       </p:nvGrpSpPr>
-      <p:grpSpPr/>
+      <p:grpSpPr>
+        <a:xfrm>
+          <a:off x="0" y="0"/>
+          <a:ext cx="0" cy="0"/>
+          <a:chOff x="0" y="0"/>
+          <a:chExt cx="0" cy="0"/>
+        </a:xfrm>
+      </p:grpSpPr>
       <p:sp>
         <p:nvSpPr>
           <p:cNvPr id="2" name="Rectangle 1"/>
@@ -6387,6 +7271,7 @@
           <a:lstStyle/>
           <a:p>
             <a:pPr algn="ctr"/>
+            <a:endParaRPr/>
           </a:p>
         </p:txBody>
       </p:sp>
@@ -6532,6 +7417,7 @@
                 </a:solidFill>
               </a:defRPr>
             </a:pPr>
+            <a:endParaRPr/>
           </a:p>
           <a:p>
             <a:pPr>
@@ -6633,8 +7519,8 @@
 </p:sld>
 </file>
 
-<file path=ppt/slides/slide5.xml><?xml version="1.0" encoding="utf-8"?>
-<p:sld xmlns:a="http://schemas.openxmlformats.org/drawingml/2006/main" xmlns:p="http://schemas.openxmlformats.org/presentationml/2006/main" xmlns:r="http://schemas.openxmlformats.org/officeDocument/2006/relationships">
+<file path=ppt/slides/slide6.xml><?xml version="1.0" encoding="utf-8"?>
+<p:sld xmlns:a="http://schemas.openxmlformats.org/drawingml/2006/main" xmlns:r="http://schemas.openxmlformats.org/officeDocument/2006/relationships" xmlns:p="http://schemas.openxmlformats.org/presentationml/2006/main">
   <p:cSld>
     <p:spTree>
       <p:nvGrpSpPr>
@@ -6642,7 +7528,14 @@
         <p:cNvGrpSpPr/>
         <p:nvPr/>
       </p:nvGrpSpPr>
-      <p:grpSpPr/>
+      <p:grpSpPr>
+        <a:xfrm>
+          <a:off x="0" y="0"/>
+          <a:ext cx="0" cy="0"/>
+          <a:chOff x="0" y="0"/>
+          <a:chExt cx="0" cy="0"/>
+        </a:xfrm>
+      </p:grpSpPr>
       <p:sp>
         <p:nvSpPr>
           <p:cNvPr id="2" name="Rectangle 1"/>
@@ -6685,6 +7578,7 @@
           <a:lstStyle/>
           <a:p>
             <a:pPr algn="ctr"/>
+            <a:endParaRPr/>
           </a:p>
         </p:txBody>
       </p:sp>
@@ -6830,6 +7724,7 @@
                 </a:solidFill>
               </a:defRPr>
             </a:pPr>
+            <a:endParaRPr/>
           </a:p>
           <a:p>
             <a:pPr>
@@ -6917,6 +7812,7 @@
                 </a:solidFill>
               </a:defRPr>
             </a:pPr>
+            <a:endParaRPr/>
           </a:p>
           <a:p>
             <a:pPr>
@@ -7000,8 +7896,8 @@
 </p:sld>
 </file>
 
-<file path=ppt/slides/slide6.xml><?xml version="1.0" encoding="utf-8"?>
-<p:sld xmlns:a="http://schemas.openxmlformats.org/drawingml/2006/main" xmlns:p="http://schemas.openxmlformats.org/presentationml/2006/main" xmlns:r="http://schemas.openxmlformats.org/officeDocument/2006/relationships">
+<file path=ppt/slides/slide7.xml><?xml version="1.0" encoding="utf-8"?>
+<p:sld xmlns:a="http://schemas.openxmlformats.org/drawingml/2006/main" xmlns:r="http://schemas.openxmlformats.org/officeDocument/2006/relationships" xmlns:p="http://schemas.openxmlformats.org/presentationml/2006/main">
   <p:cSld>
     <p:spTree>
       <p:nvGrpSpPr>
@@ -7009,7 +7905,14 @@
         <p:cNvGrpSpPr/>
         <p:nvPr/>
       </p:nvGrpSpPr>
-      <p:grpSpPr/>
+      <p:grpSpPr>
+        <a:xfrm>
+          <a:off x="0" y="0"/>
+          <a:ext cx="0" cy="0"/>
+          <a:chOff x="0" y="0"/>
+          <a:chExt cx="0" cy="0"/>
+        </a:xfrm>
+      </p:grpSpPr>
       <p:sp>
         <p:nvSpPr>
           <p:cNvPr id="2" name="Rectangle 1"/>
@@ -7052,6 +7955,7 @@
           <a:lstStyle/>
           <a:p>
             <a:pPr algn="ctr"/>
+            <a:endParaRPr/>
           </a:p>
         </p:txBody>
       </p:sp>
@@ -7161,6 +8065,7 @@
                 </a:solidFill>
               </a:defRPr>
             </a:pPr>
+            <a:endParaRPr/>
           </a:p>
           <a:p>
             <a:pPr>
@@ -7212,6 +8117,7 @@
                 </a:solidFill>
               </a:defRPr>
             </a:pPr>
+            <a:endParaRPr/>
           </a:p>
           <a:p>
             <a:pPr>
@@ -7263,6 +8169,7 @@
                 </a:solidFill>
               </a:defRPr>
             </a:pPr>
+            <a:endParaRPr/>
           </a:p>
           <a:p>
             <a:pPr>
@@ -7310,8 +8217,8 @@
 </p:sld>
 </file>
 
-<file path=ppt/slides/slide7.xml><?xml version="1.0" encoding="utf-8"?>
-<p:sld xmlns:a="http://schemas.openxmlformats.org/drawingml/2006/main" xmlns:p="http://schemas.openxmlformats.org/presentationml/2006/main" xmlns:r="http://schemas.openxmlformats.org/officeDocument/2006/relationships">
+<file path=ppt/slides/slide8.xml><?xml version="1.0" encoding="utf-8"?>
+<p:sld xmlns:a="http://schemas.openxmlformats.org/drawingml/2006/main" xmlns:r="http://schemas.openxmlformats.org/officeDocument/2006/relationships" xmlns:p="http://schemas.openxmlformats.org/presentationml/2006/main">
   <p:cSld>
     <p:spTree>
       <p:nvGrpSpPr>
@@ -7319,7 +8226,14 @@
         <p:cNvGrpSpPr/>
         <p:nvPr/>
       </p:nvGrpSpPr>
-      <p:grpSpPr/>
+      <p:grpSpPr>
+        <a:xfrm>
+          <a:off x="0" y="0"/>
+          <a:ext cx="0" cy="0"/>
+          <a:chOff x="0" y="0"/>
+          <a:chExt cx="0" cy="0"/>
+        </a:xfrm>
+      </p:grpSpPr>
       <p:sp>
         <p:nvSpPr>
           <p:cNvPr id="2" name="Rectangle 1"/>
@@ -7362,6 +8276,7 @@
           <a:lstStyle/>
           <a:p>
             <a:pPr algn="ctr"/>
+            <a:endParaRPr/>
           </a:p>
         </p:txBody>
       </p:sp>
@@ -7543,6 +8458,7 @@
                 </a:solidFill>
               </a:defRPr>
             </a:pPr>
+            <a:endParaRPr/>
           </a:p>
           <a:p>
             <a:pPr>
@@ -7572,8 +8488,8 @@
 </p:sld>
 </file>
 
-<file path=ppt/slides/slide8.xml><?xml version="1.0" encoding="utf-8"?>
-<p:sld xmlns:a="http://schemas.openxmlformats.org/drawingml/2006/main" xmlns:p="http://schemas.openxmlformats.org/presentationml/2006/main" xmlns:r="http://schemas.openxmlformats.org/officeDocument/2006/relationships">
+<file path=ppt/slides/slide9.xml><?xml version="1.0" encoding="utf-8"?>
+<p:sld xmlns:a="http://schemas.openxmlformats.org/drawingml/2006/main" xmlns:r="http://schemas.openxmlformats.org/officeDocument/2006/relationships" xmlns:p="http://schemas.openxmlformats.org/presentationml/2006/main">
   <p:cSld>
     <p:spTree>
       <p:nvGrpSpPr>
@@ -7581,7 +8497,14 @@
         <p:cNvGrpSpPr/>
         <p:nvPr/>
       </p:nvGrpSpPr>
-      <p:grpSpPr/>
+      <p:grpSpPr>
+        <a:xfrm>
+          <a:off x="0" y="0"/>
+          <a:ext cx="0" cy="0"/>
+          <a:chOff x="0" y="0"/>
+          <a:chExt cx="0" cy="0"/>
+        </a:xfrm>
+      </p:grpSpPr>
       <p:sp>
         <p:nvSpPr>
           <p:cNvPr id="2" name="Rectangle 1"/>
@@ -7624,6 +8547,7 @@
           <a:lstStyle/>
           <a:p>
             <a:pPr algn="ctr"/>
+            <a:endParaRPr/>
           </a:p>
         </p:txBody>
       </p:sp>
@@ -7769,6 +8693,7 @@
                 </a:solidFill>
               </a:defRPr>
             </a:pPr>
+            <a:endParaRPr/>
           </a:p>
           <a:p>
             <a:pPr>
@@ -7987,6 +8912,7 @@
                 </a:solidFill>
               </a:defRPr>
             </a:pPr>
+            <a:endParaRPr/>
           </a:p>
           <a:p>
             <a:pPr>
@@ -8076,307 +9002,6 @@
             </a:pPr>
             <a:r>
               <a:t>• Organizational Hierarchy</a:t>
-            </a:r>
-          </a:p>
-        </p:txBody>
-      </p:sp>
-    </p:spTree>
-  </p:cSld>
-  <p:clrMapOvr>
-    <a:masterClrMapping/>
-  </p:clrMapOvr>
-</p:sld>
-</file>
-
-<file path=ppt/slides/slide9.xml><?xml version="1.0" encoding="utf-8"?>
-<p:sld xmlns:a="http://schemas.openxmlformats.org/drawingml/2006/main" xmlns:p="http://schemas.openxmlformats.org/presentationml/2006/main" xmlns:r="http://schemas.openxmlformats.org/officeDocument/2006/relationships">
-  <p:cSld>
-    <p:spTree>
-      <p:nvGrpSpPr>
-        <p:cNvPr id="1" name=""/>
-        <p:cNvGrpSpPr/>
-        <p:nvPr/>
-      </p:nvGrpSpPr>
-      <p:grpSpPr/>
-      <p:sp>
-        <p:nvSpPr>
-          <p:cNvPr id="2" name="Rectangle 1"/>
-          <p:cNvSpPr/>
-          <p:nvPr/>
-        </p:nvSpPr>
-        <p:spPr>
-          <a:xfrm>
-            <a:off x="0" y="0"/>
-            <a:ext cx="9144000" cy="914400"/>
-          </a:xfrm>
-          <a:prstGeom prst="rect">
-            <a:avLst/>
-          </a:prstGeom>
-          <a:solidFill>
-            <a:srgbClr val="1F4E79"/>
-          </a:solidFill>
-          <a:ln>
-            <a:solidFill>
-              <a:srgbClr val="1F4E79"/>
-            </a:solidFill>
-          </a:ln>
-        </p:spPr>
-        <p:style>
-          <a:lnRef idx="1">
-            <a:schemeClr val="accent1"/>
-          </a:lnRef>
-          <a:fillRef idx="3">
-            <a:schemeClr val="accent1"/>
-          </a:fillRef>
-          <a:effectRef idx="2">
-            <a:schemeClr val="accent1"/>
-          </a:effectRef>
-          <a:fontRef idx="minor">
-            <a:schemeClr val="lt1"/>
-          </a:fontRef>
-        </p:style>
-        <p:txBody>
-          <a:bodyPr rtlCol="0" anchor="ctr"/>
-          <a:lstStyle/>
-          <a:p>
-            <a:pPr algn="ctr"/>
-          </a:p>
-        </p:txBody>
-      </p:sp>
-      <p:sp>
-        <p:nvSpPr>
-          <p:cNvPr id="3" name="TextBox 2"/>
-          <p:cNvSpPr txBox="1"/>
-          <p:nvPr/>
-        </p:nvSpPr>
-        <p:spPr>
-          <a:xfrm>
-            <a:off x="457200" y="182880"/>
-            <a:ext cx="8229600" cy="731520"/>
-          </a:xfrm>
-          <a:prstGeom prst="rect">
-            <a:avLst/>
-          </a:prstGeom>
-          <a:noFill/>
-        </p:spPr>
-        <p:txBody>
-          <a:bodyPr wrap="square">
-            <a:spAutoFit/>
-          </a:bodyPr>
-          <a:lstStyle/>
-          <a:p>
-            <a:pPr>
-              <a:defRPr sz="4000" b="1">
-                <a:solidFill>
-                  <a:srgbClr val="FFFFFF"/>
-                </a:solidFill>
-              </a:defRPr>
-            </a:pPr>
-            <a:r>
-              <a:t>Key System Features</a:t>
-            </a:r>
-          </a:p>
-        </p:txBody>
-      </p:sp>
-      <p:sp>
-        <p:nvSpPr>
-          <p:cNvPr id="4" name="TextBox 3"/>
-          <p:cNvSpPr txBox="1"/>
-          <p:nvPr/>
-        </p:nvSpPr>
-        <p:spPr>
-          <a:xfrm>
-            <a:off x="731520" y="1645920"/>
-            <a:ext cx="7680960" cy="4572000"/>
-          </a:xfrm>
-          <a:prstGeom prst="rect">
-            <a:avLst/>
-          </a:prstGeom>
-          <a:noFill/>
-        </p:spPr>
-        <p:txBody>
-          <a:bodyPr wrap="square">
-            <a:spAutoFit/>
-          </a:bodyPr>
-          <a:lstStyle/>
-          <a:p>
-            <a:pPr>
-              <a:spcBef>
-                <a:spcPts val="600"/>
-              </a:spcBef>
-              <a:spcAft>
-                <a:spcPts val="600"/>
-              </a:spcAft>
-              <a:defRPr sz="1800">
-                <a:solidFill>
-                  <a:srgbClr val="333333"/>
-                </a:solidFill>
-              </a:defRPr>
-            </a:pPr>
-            <a:r>
-              <a:t>✅ Real-time Stock Tracking</a:t>
-            </a:r>
-          </a:p>
-          <a:p>
-            <a:pPr>
-              <a:spcBef>
-                <a:spcPts val="600"/>
-              </a:spcBef>
-              <a:spcAft>
-                <a:spcPts val="600"/>
-              </a:spcAft>
-              <a:defRPr sz="1800">
-                <a:solidFill>
-                  <a:srgbClr val="333333"/>
-                </a:solidFill>
-              </a:defRPr>
-            </a:pPr>
-            <a:r>
-              <a:t>✅ Multi-Step Hierarchical Approval Workflows</a:t>
-            </a:r>
-          </a:p>
-          <a:p>
-            <a:pPr>
-              <a:spcBef>
-                <a:spcPts val="600"/>
-              </a:spcBef>
-              <a:spcAft>
-                <a:spcPts val="600"/>
-              </a:spcAft>
-              <a:defRPr sz="1800">
-                <a:solidFill>
-                  <a:srgbClr val="333333"/>
-                </a:solidFill>
-              </a:defRPr>
-            </a:pPr>
-            <a:r>
-              <a:t>✅ Complete Audit Trail &amp; History</a:t>
-            </a:r>
-          </a:p>
-          <a:p>
-            <a:pPr>
-              <a:spcBef>
-                <a:spcPts val="600"/>
-              </a:spcBef>
-              <a:spcAft>
-                <a:spcPts val="600"/>
-              </a:spcAft>
-              <a:defRPr sz="1800">
-                <a:solidFill>
-                  <a:srgbClr val="333333"/>
-                </a:solidFill>
-              </a:defRPr>
-            </a:pPr>
-            <a:r>
-              <a:t>✅ Role-Based Access Control (RBAC)</a:t>
-            </a:r>
-          </a:p>
-          <a:p>
-            <a:pPr>
-              <a:spcBef>
-                <a:spcPts val="600"/>
-              </a:spcBef>
-              <a:spcAft>
-                <a:spcPts val="600"/>
-              </a:spcAft>
-              <a:defRPr sz="1800">
-                <a:solidFill>
-                  <a:srgbClr val="333333"/>
-                </a:solidFill>
-              </a:defRPr>
-            </a:pPr>
-            <a:r>
-              <a:t>✅ Three-Level Inventory Management</a:t>
-            </a:r>
-          </a:p>
-          <a:p>
-            <a:pPr>
-              <a:spcBef>
-                <a:spcPts val="600"/>
-              </a:spcBef>
-              <a:spcAft>
-                <a:spcPts val="600"/>
-              </a:spcAft>
-              <a:defRPr sz="1800">
-                <a:solidFill>
-                  <a:srgbClr val="333333"/>
-                </a:solidFill>
-              </a:defRPr>
-            </a:pPr>
-            <a:r>
-              <a:t>✅ Multiple Tender Types Support</a:t>
-            </a:r>
-          </a:p>
-          <a:p>
-            <a:pPr>
-              <a:spcBef>
-                <a:spcPts val="600"/>
-              </a:spcBef>
-              <a:spcAft>
-                <a:spcPts val="600"/>
-              </a:spcAft>
-              <a:defRPr sz="1800">
-                <a:solidFill>
-                  <a:srgbClr val="333333"/>
-                </a:solidFill>
-              </a:defRPr>
-            </a:pPr>
-            <a:r>
-              <a:t>✅ Digital Annual Framework Contracts</a:t>
-            </a:r>
-          </a:p>
-          <a:p>
-            <a:pPr>
-              <a:spcBef>
-                <a:spcPts val="600"/>
-              </a:spcBef>
-              <a:spcAft>
-                <a:spcPts val="600"/>
-              </a:spcAft>
-              <a:defRPr sz="1800">
-                <a:solidFill>
-                  <a:srgbClr val="333333"/>
-                </a:solidFill>
-              </a:defRPr>
-            </a:pPr>
-            <a:r>
-              <a:t>✅ Serial Number &amp; Equipment Tracking</a:t>
-            </a:r>
-          </a:p>
-          <a:p>
-            <a:pPr>
-              <a:spcBef>
-                <a:spcPts val="600"/>
-              </a:spcBef>
-              <a:spcAft>
-                <a:spcPts val="600"/>
-              </a:spcAft>
-              <a:defRPr sz="1800">
-                <a:solidFill>
-                  <a:srgbClr val="333333"/>
-                </a:solidFill>
-              </a:defRPr>
-            </a:pPr>
-            <a:r>
-              <a:t>✅ Document Upload &amp; Attachment Support</a:t>
-            </a:r>
-          </a:p>
-          <a:p>
-            <a:pPr>
-              <a:spcBef>
-                <a:spcPts val="600"/>
-              </a:spcBef>
-              <a:spcAft>
-                <a:spcPts val="600"/>
-              </a:spcAft>
-              <a:defRPr sz="1800">
-                <a:solidFill>
-                  <a:srgbClr val="333333"/>
-                </a:solidFill>
-              </a:defRPr>
-            </a:pPr>
-            <a:r>
-              <a:t>✅ Soft Delete with Data Recovery</a:t>
             </a:r>
           </a:p>
         </p:txBody>

</xml_diff>